<commit_message>
Snapshot: add v5 regression scripts and p0ridge/p0zero/p0free plots
Saves current working state before neutron resolution fix pass.
Includes zdc_make_graphs_v5.C, zdc_reco_browser.C, all p0-mode PNGs.

Co-Authored-By: Claude Sonnet 4.6 <noreply@anthropic.com>
</commit_message>
<xml_diff>
--- a/plots/ZDC_Energy_Reconstruction.pptx
+++ b/plots/ZDC_Energy_Reconstruction.pptx
@@ -5,17 +5,17 @@
     <p:sldMasterId id="2147483648" r:id="rId1"/>
   </p:sldMasterIdLst>
   <p:sldIdLst>
-    <p:sldId id="256" r:id="rId7"/>
-    <p:sldId id="257" r:id="rId8"/>
-    <p:sldId id="258" r:id="rId9"/>
-    <p:sldId id="259" r:id="rId10"/>
-    <p:sldId id="260" r:id="rId11"/>
-    <p:sldId id="261" r:id="rId12"/>
-    <p:sldId id="262" r:id="rId13"/>
-    <p:sldId id="263" r:id="rId14"/>
-    <p:sldId id="264" r:id="rId15"/>
+    <p:sldId id="256" r:id="rId2"/>
+    <p:sldId id="257" r:id="rId3"/>
+    <p:sldId id="258" r:id="rId4"/>
+    <p:sldId id="259" r:id="rId5"/>
+    <p:sldId id="260" r:id="rId6"/>
+    <p:sldId id="261" r:id="rId7"/>
+    <p:sldId id="262" r:id="rId8"/>
+    <p:sldId id="263" r:id="rId9"/>
+    <p:sldId id="264" r:id="rId10"/>
   </p:sldIdLst>
-  <p:sldSz cx="12188952" cy="6858000" type="screen4x3"/>
+  <p:sldSz cx="12188825" cy="6858000"/>
   <p:notesSz cx="6858000" cy="9144000"/>
   <p:defaultTextStyle>
     <a:defPPr>
@@ -112,7 +112,52 @@
       </a:defRPr>
     </a:lvl9pPr>
   </p:defaultTextStyle>
+  <p:extLst>
+    <p:ext uri="{EFAFB233-063F-42B5-8137-9DF3F51BA10A}">
+      <p15:sldGuideLst xmlns:p15="http://schemas.microsoft.com/office/powerpoint/2012/main">
+        <p15:guide id="1" orient="horz" pos="2160">
+          <p15:clr>
+            <a:srgbClr val="A4A3A4"/>
+          </p15:clr>
+        </p15:guide>
+        <p15:guide id="2" pos="2880">
+          <p15:clr>
+            <a:srgbClr val="A4A3A4"/>
+          </p15:clr>
+        </p15:guide>
+      </p15:sldGuideLst>
+    </p:ext>
+  </p:extLst>
 </p:presentation>
+</file>
+
+<file path=ppt/changesInfos/changesInfo1.xml><?xml version="1.0" encoding="utf-8"?>
+<pc:chgInfo xmlns:a="http://schemas.openxmlformats.org/drawingml/2006/main" xmlns:r="http://schemas.openxmlformats.org/officeDocument/2006/relationships" xmlns:ac="http://schemas.microsoft.com/office/drawing/2013/main/command" xmlns:pc="http://schemas.microsoft.com/office/powerpoint/2013/main/command">
+  <pc:docChgLst>
+    <pc:chgData name="Julian Juan" userId="38360f0bb526f7b0" providerId="LiveId" clId="{3D80B024-A106-43F4-AA74-F3CFE2B880A4}"/>
+    <pc:docChg chg="modSld">
+      <pc:chgData name="Julian Juan" userId="38360f0bb526f7b0" providerId="LiveId" clId="{3D80B024-A106-43F4-AA74-F3CFE2B880A4}" dt="2026-06-24T02:15:36.351" v="19" actId="20577"/>
+      <pc:docMkLst>
+        <pc:docMk/>
+      </pc:docMkLst>
+      <pc:sldChg chg="modSp mod">
+        <pc:chgData name="Julian Juan" userId="38360f0bb526f7b0" providerId="LiveId" clId="{3D80B024-A106-43F4-AA74-F3CFE2B880A4}" dt="2026-06-24T02:15:36.351" v="19" actId="20577"/>
+        <pc:sldMkLst>
+          <pc:docMk/>
+          <pc:sldMk cId="0" sldId="257"/>
+        </pc:sldMkLst>
+        <pc:spChg chg="mod">
+          <ac:chgData name="Julian Juan" userId="38360f0bb526f7b0" providerId="LiveId" clId="{3D80B024-A106-43F4-AA74-F3CFE2B880A4}" dt="2026-06-24T02:15:36.351" v="19" actId="20577"/>
+          <ac:spMkLst>
+            <pc:docMk/>
+            <pc:sldMk cId="0" sldId="257"/>
+            <ac:spMk id="8" creationId="{00000000-0000-0000-0000-000000000000}"/>
+          </ac:spMkLst>
+        </pc:spChg>
+      </pc:sldChg>
+    </pc:docChg>
+  </pc:docChgLst>
+</pc:chgInfo>
 </file>
 
 <file path=ppt/slideLayouts/slideLayout1.xml><?xml version="1.0" encoding="utf-8"?>
@@ -153,10 +198,9 @@
           <a:lstStyle/>
           <a:p>
             <a:r>
-              <a:rPr lang="en-US" smtClean="0"/>
+              <a:rPr lang="en-US"/>
               <a:t>Click to edit Master title style</a:t>
             </a:r>
-            <a:endParaRPr lang="en-US"/>
           </a:p>
         </p:txBody>
       </p:sp>
@@ -272,10 +316,9 @@
           </a:lstStyle>
           <a:p>
             <a:r>
-              <a:rPr lang="en-US" smtClean="0"/>
+              <a:rPr lang="en-US"/>
               <a:t>Click to edit Master subtitle style</a:t>
             </a:r>
-            <a:endParaRPr lang="en-US"/>
           </a:p>
         </p:txBody>
       </p:sp>
@@ -296,7 +339,7 @@
           <a:p>
             <a:fld id="{5BCAD085-E8A6-8845-BD4E-CB4CCA059FC4}" type="datetimeFigureOut">
               <a:rPr lang="en-US" smtClean="0"/>
-              <a:t>1/27/13</a:t>
+              <a:t>6/24/2026</a:t>
             </a:fld>
             <a:endParaRPr lang="en-US"/>
           </a:p>
@@ -390,10 +433,9 @@
           <a:lstStyle/>
           <a:p>
             <a:r>
-              <a:rPr lang="en-US" smtClean="0"/>
+              <a:rPr lang="en-US"/>
               <a:t>Click to edit Master title style</a:t>
             </a:r>
-            <a:endParaRPr lang="en-US"/>
           </a:p>
         </p:txBody>
       </p:sp>
@@ -414,38 +456,37 @@
           <a:p>
             <a:pPr lvl="0"/>
             <a:r>
-              <a:rPr lang="en-US" smtClean="0"/>
+              <a:rPr lang="en-US"/>
               <a:t>Click to edit Master text styles</a:t>
             </a:r>
           </a:p>
           <a:p>
             <a:pPr lvl="1"/>
             <a:r>
-              <a:rPr lang="en-US" smtClean="0"/>
+              <a:rPr lang="en-US"/>
               <a:t>Second level</a:t>
             </a:r>
           </a:p>
           <a:p>
             <a:pPr lvl="2"/>
             <a:r>
-              <a:rPr lang="en-US" smtClean="0"/>
+              <a:rPr lang="en-US"/>
               <a:t>Third level</a:t>
             </a:r>
           </a:p>
           <a:p>
             <a:pPr lvl="3"/>
             <a:r>
-              <a:rPr lang="en-US" smtClean="0"/>
+              <a:rPr lang="en-US"/>
               <a:t>Fourth level</a:t>
             </a:r>
           </a:p>
           <a:p>
             <a:pPr lvl="4"/>
             <a:r>
-              <a:rPr lang="en-US" smtClean="0"/>
+              <a:rPr lang="en-US"/>
               <a:t>Fifth level</a:t>
             </a:r>
-            <a:endParaRPr lang="en-US"/>
           </a:p>
         </p:txBody>
       </p:sp>
@@ -466,7 +507,7 @@
           <a:p>
             <a:fld id="{5BCAD085-E8A6-8845-BD4E-CB4CCA059FC4}" type="datetimeFigureOut">
               <a:rPr lang="en-US" smtClean="0"/>
-              <a:t>1/27/13</a:t>
+              <a:t>6/24/2026</a:t>
             </a:fld>
             <a:endParaRPr lang="en-US"/>
           </a:p>
@@ -565,10 +606,9 @@
           <a:lstStyle/>
           <a:p>
             <a:r>
-              <a:rPr lang="en-US" smtClean="0"/>
+              <a:rPr lang="en-US"/>
               <a:t>Click to edit Master title style</a:t>
             </a:r>
-            <a:endParaRPr lang="en-US"/>
           </a:p>
         </p:txBody>
       </p:sp>
@@ -594,38 +634,37 @@
           <a:p>
             <a:pPr lvl="0"/>
             <a:r>
-              <a:rPr lang="en-US" smtClean="0"/>
+              <a:rPr lang="en-US"/>
               <a:t>Click to edit Master text styles</a:t>
             </a:r>
           </a:p>
           <a:p>
             <a:pPr lvl="1"/>
             <a:r>
-              <a:rPr lang="en-US" smtClean="0"/>
+              <a:rPr lang="en-US"/>
               <a:t>Second level</a:t>
             </a:r>
           </a:p>
           <a:p>
             <a:pPr lvl="2"/>
             <a:r>
-              <a:rPr lang="en-US" smtClean="0"/>
+              <a:rPr lang="en-US"/>
               <a:t>Third level</a:t>
             </a:r>
           </a:p>
           <a:p>
             <a:pPr lvl="3"/>
             <a:r>
-              <a:rPr lang="en-US" smtClean="0"/>
+              <a:rPr lang="en-US"/>
               <a:t>Fourth level</a:t>
             </a:r>
           </a:p>
           <a:p>
             <a:pPr lvl="4"/>
             <a:r>
-              <a:rPr lang="en-US" smtClean="0"/>
+              <a:rPr lang="en-US"/>
               <a:t>Fifth level</a:t>
             </a:r>
-            <a:endParaRPr lang="en-US"/>
           </a:p>
         </p:txBody>
       </p:sp>
@@ -646,7 +685,7 @@
           <a:p>
             <a:fld id="{5BCAD085-E8A6-8845-BD4E-CB4CCA059FC4}" type="datetimeFigureOut">
               <a:rPr lang="en-US" smtClean="0"/>
-              <a:t>1/27/13</a:t>
+              <a:t>6/24/2026</a:t>
             </a:fld>
             <a:endParaRPr lang="en-US"/>
           </a:p>
@@ -740,10 +779,9 @@
           <a:lstStyle/>
           <a:p>
             <a:r>
-              <a:rPr lang="en-US" smtClean="0"/>
+              <a:rPr lang="en-US"/>
               <a:t>Click to edit Master title style</a:t>
             </a:r>
-            <a:endParaRPr lang="en-US"/>
           </a:p>
         </p:txBody>
       </p:sp>
@@ -764,38 +802,37 @@
           <a:p>
             <a:pPr lvl="0"/>
             <a:r>
-              <a:rPr lang="en-US" smtClean="0"/>
+              <a:rPr lang="en-US"/>
               <a:t>Click to edit Master text styles</a:t>
             </a:r>
           </a:p>
           <a:p>
             <a:pPr lvl="1"/>
             <a:r>
-              <a:rPr lang="en-US" smtClean="0"/>
+              <a:rPr lang="en-US"/>
               <a:t>Second level</a:t>
             </a:r>
           </a:p>
           <a:p>
             <a:pPr lvl="2"/>
             <a:r>
-              <a:rPr lang="en-US" smtClean="0"/>
+              <a:rPr lang="en-US"/>
               <a:t>Third level</a:t>
             </a:r>
           </a:p>
           <a:p>
             <a:pPr lvl="3"/>
             <a:r>
-              <a:rPr lang="en-US" smtClean="0"/>
+              <a:rPr lang="en-US"/>
               <a:t>Fourth level</a:t>
             </a:r>
           </a:p>
           <a:p>
             <a:pPr lvl="4"/>
             <a:r>
-              <a:rPr lang="en-US" smtClean="0"/>
+              <a:rPr lang="en-US"/>
               <a:t>Fifth level</a:t>
             </a:r>
-            <a:endParaRPr lang="en-US"/>
           </a:p>
         </p:txBody>
       </p:sp>
@@ -816,7 +853,7 @@
           <a:p>
             <a:fld id="{5BCAD085-E8A6-8845-BD4E-CB4CCA059FC4}" type="datetimeFigureOut">
               <a:rPr lang="en-US" smtClean="0"/>
-              <a:t>1/27/13</a:t>
+              <a:t>6/24/2026</a:t>
             </a:fld>
             <a:endParaRPr lang="en-US"/>
           </a:p>
@@ -919,10 +956,9 @@
           </a:lstStyle>
           <a:p>
             <a:r>
-              <a:rPr lang="en-US" smtClean="0"/>
+              <a:rPr lang="en-US"/>
               <a:t>Click to edit Master title style</a:t>
             </a:r>
-            <a:endParaRPr lang="en-US"/>
           </a:p>
         </p:txBody>
       </p:sp>
@@ -1039,7 +1075,7 @@
           <a:p>
             <a:pPr lvl="0"/>
             <a:r>
-              <a:rPr lang="en-US" smtClean="0"/>
+              <a:rPr lang="en-US"/>
               <a:t>Click to edit Master text styles</a:t>
             </a:r>
           </a:p>
@@ -1062,7 +1098,7 @@
           <a:p>
             <a:fld id="{5BCAD085-E8A6-8845-BD4E-CB4CCA059FC4}" type="datetimeFigureOut">
               <a:rPr lang="en-US" smtClean="0"/>
-              <a:t>1/27/13</a:t>
+              <a:t>6/24/2026</a:t>
             </a:fld>
             <a:endParaRPr lang="en-US"/>
           </a:p>
@@ -1156,10 +1192,9 @@
           <a:lstStyle/>
           <a:p>
             <a:r>
-              <a:rPr lang="en-US" smtClean="0"/>
+              <a:rPr lang="en-US"/>
               <a:t>Click to edit Master title style</a:t>
             </a:r>
-            <a:endParaRPr lang="en-US"/>
           </a:p>
         </p:txBody>
       </p:sp>
@@ -1213,38 +1248,37 @@
           <a:p>
             <a:pPr lvl="0"/>
             <a:r>
-              <a:rPr lang="en-US" smtClean="0"/>
+              <a:rPr lang="en-US"/>
               <a:t>Click to edit Master text styles</a:t>
             </a:r>
           </a:p>
           <a:p>
             <a:pPr lvl="1"/>
             <a:r>
-              <a:rPr lang="en-US" smtClean="0"/>
+              <a:rPr lang="en-US"/>
               <a:t>Second level</a:t>
             </a:r>
           </a:p>
           <a:p>
             <a:pPr lvl="2"/>
             <a:r>
-              <a:rPr lang="en-US" smtClean="0"/>
+              <a:rPr lang="en-US"/>
               <a:t>Third level</a:t>
             </a:r>
           </a:p>
           <a:p>
             <a:pPr lvl="3"/>
             <a:r>
-              <a:rPr lang="en-US" smtClean="0"/>
+              <a:rPr lang="en-US"/>
               <a:t>Fourth level</a:t>
             </a:r>
           </a:p>
           <a:p>
             <a:pPr lvl="4"/>
             <a:r>
-              <a:rPr lang="en-US" smtClean="0"/>
+              <a:rPr lang="en-US"/>
               <a:t>Fifth level</a:t>
             </a:r>
-            <a:endParaRPr lang="en-US"/>
           </a:p>
         </p:txBody>
       </p:sp>
@@ -1298,38 +1332,37 @@
           <a:p>
             <a:pPr lvl="0"/>
             <a:r>
-              <a:rPr lang="en-US" smtClean="0"/>
+              <a:rPr lang="en-US"/>
               <a:t>Click to edit Master text styles</a:t>
             </a:r>
           </a:p>
           <a:p>
             <a:pPr lvl="1"/>
             <a:r>
-              <a:rPr lang="en-US" smtClean="0"/>
+              <a:rPr lang="en-US"/>
               <a:t>Second level</a:t>
             </a:r>
           </a:p>
           <a:p>
             <a:pPr lvl="2"/>
             <a:r>
-              <a:rPr lang="en-US" smtClean="0"/>
+              <a:rPr lang="en-US"/>
               <a:t>Third level</a:t>
             </a:r>
           </a:p>
           <a:p>
             <a:pPr lvl="3"/>
             <a:r>
-              <a:rPr lang="en-US" smtClean="0"/>
+              <a:rPr lang="en-US"/>
               <a:t>Fourth level</a:t>
             </a:r>
           </a:p>
           <a:p>
             <a:pPr lvl="4"/>
             <a:r>
-              <a:rPr lang="en-US" smtClean="0"/>
+              <a:rPr lang="en-US"/>
               <a:t>Fifth level</a:t>
             </a:r>
-            <a:endParaRPr lang="en-US"/>
           </a:p>
         </p:txBody>
       </p:sp>
@@ -1350,7 +1383,7 @@
           <a:p>
             <a:fld id="{5BCAD085-E8A6-8845-BD4E-CB4CCA059FC4}" type="datetimeFigureOut">
               <a:rPr lang="en-US" smtClean="0"/>
-              <a:t>1/27/13</a:t>
+              <a:t>6/24/2026</a:t>
             </a:fld>
             <a:endParaRPr lang="en-US"/>
           </a:p>
@@ -1448,10 +1481,9 @@
           </a:lstStyle>
           <a:p>
             <a:r>
-              <a:rPr lang="en-US" smtClean="0"/>
+              <a:rPr lang="en-US"/>
               <a:t>Click to edit Master title style</a:t>
             </a:r>
-            <a:endParaRPr lang="en-US"/>
           </a:p>
         </p:txBody>
       </p:sp>
@@ -1514,7 +1546,7 @@
           <a:p>
             <a:pPr lvl="0"/>
             <a:r>
-              <a:rPr lang="en-US" smtClean="0"/>
+              <a:rPr lang="en-US"/>
               <a:t>Click to edit Master text styles</a:t>
             </a:r>
           </a:p>
@@ -1570,38 +1602,37 @@
           <a:p>
             <a:pPr lvl="0"/>
             <a:r>
-              <a:rPr lang="en-US" smtClean="0"/>
+              <a:rPr lang="en-US"/>
               <a:t>Click to edit Master text styles</a:t>
             </a:r>
           </a:p>
           <a:p>
             <a:pPr lvl="1"/>
             <a:r>
-              <a:rPr lang="en-US" smtClean="0"/>
+              <a:rPr lang="en-US"/>
               <a:t>Second level</a:t>
             </a:r>
           </a:p>
           <a:p>
             <a:pPr lvl="2"/>
             <a:r>
-              <a:rPr lang="en-US" smtClean="0"/>
+              <a:rPr lang="en-US"/>
               <a:t>Third level</a:t>
             </a:r>
           </a:p>
           <a:p>
             <a:pPr lvl="3"/>
             <a:r>
-              <a:rPr lang="en-US" smtClean="0"/>
+              <a:rPr lang="en-US"/>
               <a:t>Fourth level</a:t>
             </a:r>
           </a:p>
           <a:p>
             <a:pPr lvl="4"/>
             <a:r>
-              <a:rPr lang="en-US" smtClean="0"/>
+              <a:rPr lang="en-US"/>
               <a:t>Fifth level</a:t>
             </a:r>
-            <a:endParaRPr lang="en-US"/>
           </a:p>
         </p:txBody>
       </p:sp>
@@ -1664,7 +1695,7 @@
           <a:p>
             <a:pPr lvl="0"/>
             <a:r>
-              <a:rPr lang="en-US" smtClean="0"/>
+              <a:rPr lang="en-US"/>
               <a:t>Click to edit Master text styles</a:t>
             </a:r>
           </a:p>
@@ -1720,38 +1751,37 @@
           <a:p>
             <a:pPr lvl="0"/>
             <a:r>
-              <a:rPr lang="en-US" smtClean="0"/>
+              <a:rPr lang="en-US"/>
               <a:t>Click to edit Master text styles</a:t>
             </a:r>
           </a:p>
           <a:p>
             <a:pPr lvl="1"/>
             <a:r>
-              <a:rPr lang="en-US" smtClean="0"/>
+              <a:rPr lang="en-US"/>
               <a:t>Second level</a:t>
             </a:r>
           </a:p>
           <a:p>
             <a:pPr lvl="2"/>
             <a:r>
-              <a:rPr lang="en-US" smtClean="0"/>
+              <a:rPr lang="en-US"/>
               <a:t>Third level</a:t>
             </a:r>
           </a:p>
           <a:p>
             <a:pPr lvl="3"/>
             <a:r>
-              <a:rPr lang="en-US" smtClean="0"/>
+              <a:rPr lang="en-US"/>
               <a:t>Fourth level</a:t>
             </a:r>
           </a:p>
           <a:p>
             <a:pPr lvl="4"/>
             <a:r>
-              <a:rPr lang="en-US" smtClean="0"/>
+              <a:rPr lang="en-US"/>
               <a:t>Fifth level</a:t>
             </a:r>
-            <a:endParaRPr lang="en-US"/>
           </a:p>
         </p:txBody>
       </p:sp>
@@ -1772,7 +1802,7 @@
           <a:p>
             <a:fld id="{5BCAD085-E8A6-8845-BD4E-CB4CCA059FC4}" type="datetimeFigureOut">
               <a:rPr lang="en-US" smtClean="0"/>
-              <a:t>1/27/13</a:t>
+              <a:t>6/24/2026</a:t>
             </a:fld>
             <a:endParaRPr lang="en-US"/>
           </a:p>
@@ -1866,10 +1896,9 @@
           <a:lstStyle/>
           <a:p>
             <a:r>
-              <a:rPr lang="en-US" smtClean="0"/>
+              <a:rPr lang="en-US"/>
               <a:t>Click to edit Master title style</a:t>
             </a:r>
-            <a:endParaRPr lang="en-US"/>
           </a:p>
         </p:txBody>
       </p:sp>
@@ -1890,7 +1919,7 @@
           <a:p>
             <a:fld id="{5BCAD085-E8A6-8845-BD4E-CB4CCA059FC4}" type="datetimeFigureOut">
               <a:rPr lang="en-US" smtClean="0"/>
-              <a:t>1/27/13</a:t>
+              <a:t>6/24/2026</a:t>
             </a:fld>
             <a:endParaRPr lang="en-US"/>
           </a:p>
@@ -1985,7 +2014,7 @@
           <a:p>
             <a:fld id="{5BCAD085-E8A6-8845-BD4E-CB4CCA059FC4}" type="datetimeFigureOut">
               <a:rPr lang="en-US" smtClean="0"/>
-              <a:t>1/27/13</a:t>
+              <a:t>6/24/2026</a:t>
             </a:fld>
             <a:endParaRPr lang="en-US"/>
           </a:p>
@@ -2088,10 +2117,9 @@
           </a:lstStyle>
           <a:p>
             <a:r>
-              <a:rPr lang="en-US" smtClean="0"/>
+              <a:rPr lang="en-US"/>
               <a:t>Click to edit Master title style</a:t>
             </a:r>
-            <a:endParaRPr lang="en-US"/>
           </a:p>
         </p:txBody>
       </p:sp>
@@ -2145,38 +2173,37 @@
           <a:p>
             <a:pPr lvl="0"/>
             <a:r>
-              <a:rPr lang="en-US" smtClean="0"/>
+              <a:rPr lang="en-US"/>
               <a:t>Click to edit Master text styles</a:t>
             </a:r>
           </a:p>
           <a:p>
             <a:pPr lvl="1"/>
             <a:r>
-              <a:rPr lang="en-US" smtClean="0"/>
+              <a:rPr lang="en-US"/>
               <a:t>Second level</a:t>
             </a:r>
           </a:p>
           <a:p>
             <a:pPr lvl="2"/>
             <a:r>
-              <a:rPr lang="en-US" smtClean="0"/>
+              <a:rPr lang="en-US"/>
               <a:t>Third level</a:t>
             </a:r>
           </a:p>
           <a:p>
             <a:pPr lvl="3"/>
             <a:r>
-              <a:rPr lang="en-US" smtClean="0"/>
+              <a:rPr lang="en-US"/>
               <a:t>Fourth level</a:t>
             </a:r>
           </a:p>
           <a:p>
             <a:pPr lvl="4"/>
             <a:r>
-              <a:rPr lang="en-US" smtClean="0"/>
+              <a:rPr lang="en-US"/>
               <a:t>Fifth level</a:t>
             </a:r>
-            <a:endParaRPr lang="en-US"/>
           </a:p>
         </p:txBody>
       </p:sp>
@@ -2239,7 +2266,7 @@
           <a:p>
             <a:pPr lvl="0"/>
             <a:r>
-              <a:rPr lang="en-US" smtClean="0"/>
+              <a:rPr lang="en-US"/>
               <a:t>Click to edit Master text styles</a:t>
             </a:r>
           </a:p>
@@ -2262,7 +2289,7 @@
           <a:p>
             <a:fld id="{5BCAD085-E8A6-8845-BD4E-CB4CCA059FC4}" type="datetimeFigureOut">
               <a:rPr lang="en-US" smtClean="0"/>
-              <a:t>1/27/13</a:t>
+              <a:t>6/24/2026</a:t>
             </a:fld>
             <a:endParaRPr lang="en-US"/>
           </a:p>
@@ -2365,10 +2392,9 @@
           </a:lstStyle>
           <a:p>
             <a:r>
-              <a:rPr lang="en-US" smtClean="0"/>
+              <a:rPr lang="en-US"/>
               <a:t>Click to edit Master title style</a:t>
             </a:r>
-            <a:endParaRPr lang="en-US"/>
           </a:p>
         </p:txBody>
       </p:sp>
@@ -2492,7 +2518,7 @@
           <a:p>
             <a:pPr lvl="0"/>
             <a:r>
-              <a:rPr lang="en-US" smtClean="0"/>
+              <a:rPr lang="en-US"/>
               <a:t>Click to edit Master text styles</a:t>
             </a:r>
           </a:p>
@@ -2515,7 +2541,7 @@
           <a:p>
             <a:fld id="{5BCAD085-E8A6-8845-BD4E-CB4CCA059FC4}" type="datetimeFigureOut">
               <a:rPr lang="en-US" smtClean="0"/>
-              <a:t>1/27/13</a:t>
+              <a:t>6/24/2026</a:t>
             </a:fld>
             <a:endParaRPr lang="en-US"/>
           </a:p>
@@ -2624,10 +2650,9 @@
           <a:lstStyle/>
           <a:p>
             <a:r>
-              <a:rPr lang="en-US" smtClean="0"/>
+              <a:rPr lang="en-US"/>
               <a:t>Click to edit Master title style</a:t>
             </a:r>
-            <a:endParaRPr lang="en-US"/>
           </a:p>
         </p:txBody>
       </p:sp>
@@ -2658,38 +2683,37 @@
           <a:p>
             <a:pPr lvl="0"/>
             <a:r>
-              <a:rPr lang="en-US" smtClean="0"/>
+              <a:rPr lang="en-US"/>
               <a:t>Click to edit Master text styles</a:t>
             </a:r>
           </a:p>
           <a:p>
             <a:pPr lvl="1"/>
             <a:r>
-              <a:rPr lang="en-US" smtClean="0"/>
+              <a:rPr lang="en-US"/>
               <a:t>Second level</a:t>
             </a:r>
           </a:p>
           <a:p>
             <a:pPr lvl="2"/>
             <a:r>
-              <a:rPr lang="en-US" smtClean="0"/>
+              <a:rPr lang="en-US"/>
               <a:t>Third level</a:t>
             </a:r>
           </a:p>
           <a:p>
             <a:pPr lvl="3"/>
             <a:r>
-              <a:rPr lang="en-US" smtClean="0"/>
+              <a:rPr lang="en-US"/>
               <a:t>Fourth level</a:t>
             </a:r>
           </a:p>
           <a:p>
             <a:pPr lvl="4"/>
             <a:r>
-              <a:rPr lang="en-US" smtClean="0"/>
+              <a:rPr lang="en-US"/>
               <a:t>Fifth level</a:t>
             </a:r>
-            <a:endParaRPr lang="en-US"/>
           </a:p>
         </p:txBody>
       </p:sp>
@@ -2728,7 +2752,7 @@
           <a:p>
             <a:fld id="{5BCAD085-E8A6-8845-BD4E-CB4CCA059FC4}" type="datetimeFigureOut">
               <a:rPr lang="en-US" smtClean="0"/>
-              <a:t>1/27/13</a:t>
+              <a:t>6/24/2026</a:t>
             </a:fld>
             <a:endParaRPr lang="en-US"/>
           </a:p>
@@ -3087,7 +3111,7 @@
 </file>
 
 <file path=ppt/slides/slide1.xml><?xml version="1.0" encoding="utf-8"?>
-<p:sld xmlns:a="http://schemas.openxmlformats.org/drawingml/2006/main" xmlns:p="http://schemas.openxmlformats.org/presentationml/2006/main" xmlns:r="http://schemas.openxmlformats.org/officeDocument/2006/relationships">
+<p:sld xmlns:a="http://schemas.openxmlformats.org/drawingml/2006/main" xmlns:r="http://schemas.openxmlformats.org/officeDocument/2006/relationships" xmlns:p="http://schemas.openxmlformats.org/presentationml/2006/main">
   <p:cSld>
     <p:bg>
       <p:bgPr>
@@ -3103,7 +3127,14 @@
         <p:cNvGrpSpPr/>
         <p:nvPr/>
       </p:nvGrpSpPr>
-      <p:grpSpPr/>
+      <p:grpSpPr>
+        <a:xfrm>
+          <a:off x="0" y="0"/>
+          <a:ext cx="0" cy="0"/>
+          <a:chOff x="0" y="0"/>
+          <a:chExt cx="0" cy="0"/>
+        </a:xfrm>
+      </p:grpSpPr>
       <p:sp>
         <p:nvSpPr>
           <p:cNvPr id="2" name="Rectangle 1"/>
@@ -3144,6 +3175,7 @@
           <a:lstStyle/>
           <a:p>
             <a:pPr algn="ctr"/>
+            <a:endParaRPr/>
           </a:p>
         </p:txBody>
       </p:sp>
@@ -3287,6 +3319,7 @@
           <a:lstStyle/>
           <a:p>
             <a:pPr algn="ctr"/>
+            <a:endParaRPr/>
           </a:p>
         </p:txBody>
       </p:sp>
@@ -3347,14 +3380,11 @@
                 <a:spcPts val="400"/>
               </a:spcBef>
             </a:pPr>
-            <a:r>
-              <a:rPr sz="1600" b="0">
-                <a:solidFill>
-                  <a:srgbClr val="FFFFFF"/>
-                </a:solidFill>
-              </a:rPr>
-              <a:t/>
-            </a:r>
+            <a:endParaRPr sz="1600" b="0">
+              <a:solidFill>
+                <a:srgbClr val="FFFFFF"/>
+              </a:solidFill>
+            </a:endParaRPr>
           </a:p>
           <a:p>
             <a:pPr algn="l">
@@ -3437,13 +3467,25 @@
                 <a:spcPts val="200"/>
               </a:spcBef>
             </a:pPr>
+            <a:endParaRPr sz="1400" b="1">
+              <a:solidFill>
+                <a:srgbClr val="FFD700"/>
+              </a:solidFill>
+            </a:endParaRPr>
+          </a:p>
+          <a:p>
+            <a:pPr algn="l">
+              <a:spcBef>
+                <a:spcPts val="200"/>
+              </a:spcBef>
+            </a:pPr>
             <a:r>
               <a:rPr sz="1400" b="0">
                 <a:solidFill>
-                  <a:srgbClr val="FFFFFF"/>
-                </a:solidFill>
-              </a:rPr>
-              <a:t/>
+                  <a:srgbClr val="D0E8F5"/>
+                </a:solidFill>
+              </a:rPr>
+              <a:t>ECAL  —  LYSO crystals + SiPM</a:t>
             </a:r>
           </a:p>
           <a:p>
@@ -3455,10 +3497,37 @@
             <a:r>
               <a:rPr sz="1400" b="0">
                 <a:solidFill>
+                  <a:srgbClr val="CCCCCC"/>
+                </a:solidFill>
+              </a:rPr>
+              <a:t>Detects: photons, electrons</a:t>
+            </a:r>
+          </a:p>
+          <a:p>
+            <a:pPr algn="l">
+              <a:spcBef>
+                <a:spcPts val="200"/>
+              </a:spcBef>
+            </a:pPr>
+            <a:endParaRPr sz="1400" b="0">
+              <a:solidFill>
+                <a:srgbClr val="CCCCCC"/>
+              </a:solidFill>
+            </a:endParaRPr>
+          </a:p>
+          <a:p>
+            <a:pPr algn="l">
+              <a:spcBef>
+                <a:spcPts val="200"/>
+              </a:spcBef>
+            </a:pPr>
+            <a:r>
+              <a:rPr sz="1400" b="0">
+                <a:solidFill>
                   <a:srgbClr val="D0E8F5"/>
                 </a:solidFill>
               </a:rPr>
-              <a:t>ECAL  —  LYSO crystals + SiPM</a:t>
+              <a:t>HCAL  —  Steel + scintillator</a:t>
             </a:r>
           </a:p>
           <a:p>
@@ -3473,7 +3542,7 @@
                   <a:srgbClr val="CCCCCC"/>
                 </a:solidFill>
               </a:rPr>
-              <a:t>Detects: photons, electrons</a:t>
+              <a:t>Detects: neutrons, hadrons</a:t>
             </a:r>
           </a:p>
           <a:p>
@@ -3482,59 +3551,11 @@
                 <a:spcPts val="200"/>
               </a:spcBef>
             </a:pPr>
-            <a:r>
-              <a:rPr sz="1400" b="0">
-                <a:solidFill>
-                  <a:srgbClr val="FFFFFF"/>
-                </a:solidFill>
-              </a:rPr>
-              <a:t/>
-            </a:r>
-          </a:p>
-          <a:p>
-            <a:pPr algn="l">
-              <a:spcBef>
-                <a:spcPts val="200"/>
-              </a:spcBef>
-            </a:pPr>
-            <a:r>
-              <a:rPr sz="1400" b="0">
-                <a:solidFill>
-                  <a:srgbClr val="D0E8F5"/>
-                </a:solidFill>
-              </a:rPr>
-              <a:t>HCAL  —  Steel + scintillator</a:t>
-            </a:r>
-          </a:p>
-          <a:p>
-            <a:pPr algn="l">
-              <a:spcBef>
-                <a:spcPts val="200"/>
-              </a:spcBef>
-            </a:pPr>
-            <a:r>
-              <a:rPr sz="1400" b="0">
-                <a:solidFill>
-                  <a:srgbClr val="CCCCCC"/>
-                </a:solidFill>
-              </a:rPr>
-              <a:t>Detects: neutrons, hadrons</a:t>
-            </a:r>
-          </a:p>
-          <a:p>
-            <a:pPr algn="l">
-              <a:spcBef>
-                <a:spcPts val="200"/>
-              </a:spcBef>
-            </a:pPr>
-            <a:r>
-              <a:rPr sz="1400" b="0">
-                <a:solidFill>
-                  <a:srgbClr val="FFFFFF"/>
-                </a:solidFill>
-              </a:rPr>
-              <a:t/>
-            </a:r>
+            <a:endParaRPr sz="1400" b="0">
+              <a:solidFill>
+                <a:srgbClr val="CCCCCC"/>
+              </a:solidFill>
+            </a:endParaRPr>
           </a:p>
           <a:p>
             <a:pPr algn="l">
@@ -3608,6 +3629,7 @@
           <a:lstStyle/>
           <a:p>
             <a:pPr algn="ctr"/>
+            <a:endParaRPr/>
           </a:p>
         </p:txBody>
       </p:sp>
@@ -3652,7 +3674,7 @@
 </file>
 
 <file path=ppt/slides/slide2.xml><?xml version="1.0" encoding="utf-8"?>
-<p:sld xmlns:a="http://schemas.openxmlformats.org/drawingml/2006/main" xmlns:p="http://schemas.openxmlformats.org/presentationml/2006/main" xmlns:r="http://schemas.openxmlformats.org/officeDocument/2006/relationships">
+<p:sld xmlns:a="http://schemas.openxmlformats.org/drawingml/2006/main" xmlns:r="http://schemas.openxmlformats.org/officeDocument/2006/relationships" xmlns:p="http://schemas.openxmlformats.org/presentationml/2006/main">
   <p:cSld>
     <p:bg>
       <p:bgPr>
@@ -3668,7 +3690,14 @@
         <p:cNvGrpSpPr/>
         <p:nvPr/>
       </p:nvGrpSpPr>
-      <p:grpSpPr/>
+      <p:grpSpPr>
+        <a:xfrm>
+          <a:off x="0" y="0"/>
+          <a:ext cx="0" cy="0"/>
+          <a:chOff x="0" y="0"/>
+          <a:chExt cx="0" cy="0"/>
+        </a:xfrm>
+      </p:grpSpPr>
       <p:sp>
         <p:nvSpPr>
           <p:cNvPr id="2" name="Rectangle 1"/>
@@ -3709,6 +3738,7 @@
           <a:lstStyle/>
           <a:p>
             <a:pPr algn="ctr"/>
+            <a:endParaRPr/>
           </a:p>
         </p:txBody>
       </p:sp>
@@ -3752,6 +3782,7 @@
           <a:lstStyle/>
           <a:p>
             <a:pPr algn="ctr"/>
+            <a:endParaRPr/>
           </a:p>
         </p:txBody>
       </p:sp>
@@ -3859,6 +3890,7 @@
           <a:lstStyle/>
           <a:p>
             <a:pPr algn="ctr"/>
+            <a:endParaRPr/>
           </a:p>
         </p:txBody>
       </p:sp>
@@ -3919,13 +3951,25 @@
                 <a:spcPts val="100"/>
               </a:spcBef>
             </a:pPr>
+            <a:endParaRPr sz="1300" b="0">
+              <a:solidFill>
+                <a:srgbClr val="D0E8F5"/>
+              </a:solidFill>
+            </a:endParaRPr>
+          </a:p>
+          <a:p>
+            <a:pPr algn="l">
+              <a:spcBef>
+                <a:spcPts val="100"/>
+              </a:spcBef>
+            </a:pPr>
             <a:r>
               <a:rPr sz="1300" b="0">
                 <a:solidFill>
                   <a:srgbClr val="FFFFFF"/>
                 </a:solidFill>
               </a:rPr>
-              <a:t/>
+              <a:t>  E_beam   True beam energy (GeV). Set by simulation. This is what we want to reconstruct.</a:t>
             </a:r>
           </a:p>
           <a:p>
@@ -3940,7 +3984,7 @@
                   <a:srgbClr val="FFFFFF"/>
                 </a:solidFill>
               </a:rPr>
-              <a:t>  E_beam   True beam energy (GeV). Set by simulation. This is what we want to reconstruct.</a:t>
+              <a:t>  E_ECAL   Energy deposited in the ECAL layer (GeV). Measured signal.</a:t>
             </a:r>
           </a:p>
           <a:p>
@@ -3955,7 +3999,7 @@
                   <a:srgbClr val="FFFFFF"/>
                 </a:solidFill>
               </a:rPr>
-              <a:t>  E_ECAL   Energy deposited in the ECAL layer (GeV). Measured signal.</a:t>
+              <a:t>  E_HCAL   Energy deposited in the HCAL layer (GeV). Measured signal.</a:t>
             </a:r>
           </a:p>
           <a:p>
@@ -3964,13 +4008,25 @@
                 <a:spcPts val="100"/>
               </a:spcBef>
             </a:pPr>
+            <a:endParaRPr sz="1300" b="0">
+              <a:solidFill>
+                <a:srgbClr val="FFFFFF"/>
+              </a:solidFill>
+            </a:endParaRPr>
+          </a:p>
+          <a:p>
+            <a:pPr algn="l">
+              <a:spcBef>
+                <a:spcPts val="100"/>
+              </a:spcBef>
+            </a:pPr>
             <a:r>
               <a:rPr sz="1300" b="0">
                 <a:solidFill>
-                  <a:srgbClr val="FFFFFF"/>
-                </a:solidFill>
-              </a:rPr>
-              <a:t>  E_HCAL   Energy deposited in the HCAL layer (GeV). Measured signal.</a:t>
+                  <a:srgbClr val="CCCCCC"/>
+                </a:solidFill>
+              </a:rPr>
+              <a:t>These three numbers exist for every event. All other quantities are derived.</a:t>
             </a:r>
           </a:p>
           <a:p>
@@ -3979,13 +4035,40 @@
                 <a:spcPts val="100"/>
               </a:spcBef>
             </a:pPr>
+            <a:endParaRPr sz="1300" b="0">
+              <a:solidFill>
+                <a:srgbClr val="CCCCCC"/>
+              </a:solidFill>
+            </a:endParaRPr>
+          </a:p>
+          <a:p>
+            <a:pPr algn="l">
+              <a:spcBef>
+                <a:spcPts val="100"/>
+              </a:spcBef>
+            </a:pPr>
+            <a:r>
+              <a:rPr sz="1300" b="1">
+                <a:solidFill>
+                  <a:srgbClr val="FFD700"/>
+                </a:solidFill>
+              </a:rPr>
+              <a:t>Step 2 — Energy reconstruction</a:t>
+            </a:r>
+          </a:p>
+          <a:p>
+            <a:pPr algn="l">
+              <a:spcBef>
+                <a:spcPts val="100"/>
+              </a:spcBef>
+            </a:pPr>
             <a:r>
               <a:rPr sz="1300" b="0">
                 <a:solidFill>
-                  <a:srgbClr val="FFFFFF"/>
-                </a:solidFill>
-              </a:rPr>
-              <a:t/>
+                  <a:srgbClr val="D0E8F5"/>
+                </a:solidFill>
+              </a:rPr>
+              <a:t>Combine the two detector signals into one energy estimate:</a:t>
             </a:r>
           </a:p>
           <a:p>
@@ -3994,13 +4077,25 @@
                 <a:spcPts val="100"/>
               </a:spcBef>
             </a:pPr>
+            <a:endParaRPr sz="1300" b="0">
+              <a:solidFill>
+                <a:srgbClr val="D0E8F5"/>
+              </a:solidFill>
+            </a:endParaRPr>
+          </a:p>
+          <a:p>
+            <a:pPr algn="l">
+              <a:spcBef>
+                <a:spcPts val="100"/>
+              </a:spcBef>
+            </a:pPr>
             <a:r>
               <a:rPr sz="1300" b="0">
                 <a:solidFill>
-                  <a:srgbClr val="CCCCCC"/>
-                </a:solidFill>
-              </a:rPr>
-              <a:t>These three numbers exist for every event. All other quantities are derived.</a:t>
+                  <a:srgbClr val="5CD65C"/>
+                </a:solidFill>
+              </a:rPr>
+              <a:t>  E_rec  =  p0 + p1·E_ECAL + p2·E_HCAL</a:t>
             </a:r>
           </a:p>
           <a:p>
@@ -4009,89 +4104,11 @@
                 <a:spcPts val="100"/>
               </a:spcBef>
             </a:pPr>
-            <a:r>
-              <a:rPr sz="1300" b="0">
-                <a:solidFill>
-                  <a:srgbClr val="FFFFFF"/>
-                </a:solidFill>
-              </a:rPr>
-              <a:t/>
-            </a:r>
-          </a:p>
-          <a:p>
-            <a:pPr algn="l">
-              <a:spcBef>
-                <a:spcPts val="100"/>
-              </a:spcBef>
-            </a:pPr>
-            <a:r>
-              <a:rPr sz="1300" b="1">
-                <a:solidFill>
-                  <a:srgbClr val="FFD700"/>
-                </a:solidFill>
-              </a:rPr>
-              <a:t>Step 2 — Energy reconstruction</a:t>
-            </a:r>
-          </a:p>
-          <a:p>
-            <a:pPr algn="l">
-              <a:spcBef>
-                <a:spcPts val="100"/>
-              </a:spcBef>
-            </a:pPr>
-            <a:r>
-              <a:rPr sz="1300" b="0">
-                <a:solidFill>
-                  <a:srgbClr val="D0E8F5"/>
-                </a:solidFill>
-              </a:rPr>
-              <a:t>Combine the two detector signals into one energy estimate:</a:t>
-            </a:r>
-          </a:p>
-          <a:p>
-            <a:pPr algn="l">
-              <a:spcBef>
-                <a:spcPts val="100"/>
-              </a:spcBef>
-            </a:pPr>
-            <a:r>
-              <a:rPr sz="1300" b="0">
-                <a:solidFill>
-                  <a:srgbClr val="FFFFFF"/>
-                </a:solidFill>
-              </a:rPr>
-              <a:t/>
-            </a:r>
-          </a:p>
-          <a:p>
-            <a:pPr algn="l">
-              <a:spcBef>
-                <a:spcPts val="100"/>
-              </a:spcBef>
-            </a:pPr>
-            <a:r>
-              <a:rPr sz="1300" b="0">
-                <a:solidFill>
-                  <a:srgbClr val="5CD65C"/>
-                </a:solidFill>
-              </a:rPr>
-              <a:t>  E_rec  =  p0 + p1·E_ECAL + p2·E_HCAL</a:t>
-            </a:r>
-          </a:p>
-          <a:p>
-            <a:pPr algn="l">
-              <a:spcBef>
-                <a:spcPts val="100"/>
-              </a:spcBef>
-            </a:pPr>
-            <a:r>
-              <a:rPr sz="1300" b="0">
-                <a:solidFill>
-                  <a:srgbClr val="FFFFFF"/>
-                </a:solidFill>
-              </a:rPr>
-              <a:t/>
-            </a:r>
+            <a:endParaRPr sz="1300" b="0">
+              <a:solidFill>
+                <a:srgbClr val="5CD65C"/>
+              </a:solidFill>
+            </a:endParaRPr>
           </a:p>
           <a:p>
             <a:pPr algn="l">
@@ -4205,7 +4222,7 @@
               </a:spcBef>
             </a:pPr>
             <a:r>
-              <a:rPr sz="1300" b="1">
+              <a:rPr sz="1300" b="1" dirty="0">
                 <a:solidFill>
                   <a:srgbClr val="FFD700"/>
                 </a:solidFill>
@@ -4219,13 +4236,81 @@
                 <a:spcPts val="100"/>
               </a:spcBef>
             </a:pPr>
-            <a:r>
-              <a:rPr sz="1300" b="0">
+            <a:endParaRPr sz="1300" b="1" dirty="0">
+              <a:solidFill>
+                <a:srgbClr val="FFD700"/>
+              </a:solidFill>
+            </a:endParaRPr>
+          </a:p>
+          <a:p>
+            <a:pPr algn="l">
+              <a:spcBef>
+                <a:spcPts val="100"/>
+              </a:spcBef>
+            </a:pPr>
+            <a:r>
+              <a:rPr sz="1300" b="0" dirty="0">
+                <a:solidFill>
+                  <a:srgbClr val="5CD65C"/>
+                </a:solidFill>
+              </a:rPr>
+              <a:t>  r  =  </a:t>
+            </a:r>
+            <a:r>
+              <a:rPr sz="1300" b="0" dirty="0" err="1">
+                <a:solidFill>
+                  <a:srgbClr val="5CD65C"/>
+                </a:solidFill>
+              </a:rPr>
+              <a:t>E_rec</a:t>
+            </a:r>
+            <a:r>
+              <a:rPr sz="1300" b="0" dirty="0">
+                <a:solidFill>
+                  <a:srgbClr val="5CD65C"/>
+                </a:solidFill>
+              </a:rPr>
+              <a:t> / </a:t>
+            </a:r>
+            <a:r>
+              <a:rPr sz="1300" b="0" dirty="0" err="1">
+                <a:solidFill>
+                  <a:srgbClr val="5CD65C"/>
+                </a:solidFill>
+              </a:rPr>
+              <a:t>E_beam</a:t>
+            </a:r>
+            <a:endParaRPr sz="1300" b="0" dirty="0">
+              <a:solidFill>
+                <a:srgbClr val="5CD65C"/>
+              </a:solidFill>
+            </a:endParaRPr>
+          </a:p>
+          <a:p>
+            <a:pPr algn="l">
+              <a:spcBef>
+                <a:spcPts val="100"/>
+              </a:spcBef>
+            </a:pPr>
+            <a:endParaRPr sz="1300" b="0" dirty="0">
+              <a:solidFill>
+                <a:srgbClr val="5CD65C"/>
+              </a:solidFill>
+            </a:endParaRPr>
+          </a:p>
+          <a:p>
+            <a:pPr algn="l">
+              <a:spcBef>
+                <a:spcPts val="100"/>
+              </a:spcBef>
+            </a:pPr>
+            <a:r>
+              <a:rPr sz="1300" b="0" dirty="0">
                 <a:solidFill>
                   <a:srgbClr val="FFFFFF"/>
                 </a:solidFill>
               </a:rPr>
-              <a:t/>
+              <a:t>r = 1.0  →  perfect reconstruction</a:t>
             </a:r>
           </a:p>
           <a:p>
@@ -4235,12 +4320,126 @@
               </a:spcBef>
             </a:pPr>
             <a:r>
-              <a:rPr sz="1300" b="0">
+              <a:rPr sz="1300" b="0" dirty="0">
+                <a:solidFill>
+                  <a:srgbClr val="FFFFFF"/>
+                </a:solidFill>
+              </a:rPr>
+              <a:t>r &gt; 1.0  →  overestimated</a:t>
+            </a:r>
+          </a:p>
+          <a:p>
+            <a:pPr algn="l">
+              <a:spcBef>
+                <a:spcPts val="100"/>
+              </a:spcBef>
+            </a:pPr>
+            <a:r>
+              <a:rPr sz="1300" b="0" dirty="0">
+                <a:solidFill>
+                  <a:srgbClr val="FFFFFF"/>
+                </a:solidFill>
+              </a:rPr>
+              <a:t>r &lt; 1.0  →  underestimated</a:t>
+            </a:r>
+          </a:p>
+          <a:p>
+            <a:pPr algn="l">
+              <a:spcBef>
+                <a:spcPts val="100"/>
+              </a:spcBef>
+            </a:pPr>
+            <a:endParaRPr sz="1300" b="0" dirty="0">
+              <a:solidFill>
+                <a:srgbClr val="FFFFFF"/>
+              </a:solidFill>
+            </a:endParaRPr>
+          </a:p>
+          <a:p>
+            <a:pPr algn="l">
+              <a:spcBef>
+                <a:spcPts val="100"/>
+              </a:spcBef>
+            </a:pPr>
+            <a:r>
+              <a:rPr sz="1300" b="1" dirty="0">
+                <a:solidFill>
+                  <a:srgbClr val="FFD700"/>
+                </a:solidFill>
+              </a:rPr>
+              <a:t>Step 4 — Histogram &amp; DCB fit</a:t>
+            </a:r>
+          </a:p>
+          <a:p>
+            <a:pPr algn="l">
+              <a:spcBef>
+                <a:spcPts val="100"/>
+              </a:spcBef>
+            </a:pPr>
+            <a:r>
+              <a:rPr sz="1300" b="0" dirty="0">
+                <a:solidFill>
+                  <a:srgbClr val="FFFFFF"/>
+                </a:solidFill>
+              </a:rPr>
+              <a:t>Collect r for all events at one beam energy.</a:t>
+            </a:r>
+          </a:p>
+          <a:p>
+            <a:pPr algn="l">
+              <a:spcBef>
+                <a:spcPts val="100"/>
+              </a:spcBef>
+            </a:pPr>
+            <a:r>
+              <a:rPr sz="1300" b="0" dirty="0">
+                <a:solidFill>
+                  <a:srgbClr val="FFFFFF"/>
+                </a:solidFill>
+              </a:rPr>
+              <a:t>Fit with Double Crystal Ball (bell curve with power-law tails).</a:t>
+            </a:r>
+          </a:p>
+          <a:p>
+            <a:pPr algn="l">
+              <a:spcBef>
+                <a:spcPts val="100"/>
+              </a:spcBef>
+            </a:pPr>
+            <a:r>
+              <a:rPr sz="1300" b="0" dirty="0">
+                <a:solidFill>
+                  <a:srgbClr val="D0E8F5"/>
+                </a:solidFill>
+              </a:rPr>
+              <a:t>Extract two numbers:</a:t>
+            </a:r>
+          </a:p>
+          <a:p>
+            <a:pPr algn="l">
+              <a:spcBef>
+                <a:spcPts val="100"/>
+              </a:spcBef>
+            </a:pPr>
+            <a:endParaRPr sz="1300" b="0" dirty="0">
+              <a:solidFill>
+                <a:srgbClr val="D0E8F5"/>
+              </a:solidFill>
+            </a:endParaRPr>
+          </a:p>
+          <a:p>
+            <a:pPr algn="l">
+              <a:spcBef>
+                <a:spcPts val="100"/>
+              </a:spcBef>
+            </a:pPr>
+            <a:r>
+              <a:rPr sz="1300" b="0" dirty="0">
                 <a:solidFill>
                   <a:srgbClr val="5CD65C"/>
                 </a:solidFill>
               </a:rPr>
-              <a:t>  r  =  E_rec / E_beam</a:t>
+              <a:t>  μ  (mu)    =  mean of fit  →  bias</a:t>
             </a:r>
           </a:p>
           <a:p>
@@ -4250,12 +4449,82 @@
               </a:spcBef>
             </a:pPr>
             <a:r>
-              <a:rPr sz="1300" b="0">
+              <a:rPr sz="1300" b="0" dirty="0">
+                <a:solidFill>
+                  <a:srgbClr val="5CD65C"/>
+                </a:solidFill>
+              </a:rPr>
+              <a:t>  σ  (sigma) =  width of fit →  resolution</a:t>
+            </a:r>
+          </a:p>
+          <a:p>
+            <a:pPr algn="l">
+              <a:spcBef>
+                <a:spcPts val="100"/>
+              </a:spcBef>
+            </a:pPr>
+            <a:endParaRPr sz="1300" b="0" dirty="0">
+              <a:solidFill>
+                <a:srgbClr val="5CD65C"/>
+              </a:solidFill>
+            </a:endParaRPr>
+          </a:p>
+          <a:p>
+            <a:pPr algn="l">
+              <a:spcBef>
+                <a:spcPts val="100"/>
+              </a:spcBef>
+            </a:pPr>
+            <a:r>
+              <a:rPr sz="1300" b="1" dirty="0">
+                <a:solidFill>
+                  <a:srgbClr val="FFD700"/>
+                </a:solidFill>
+              </a:rPr>
+              <a:t>Step 5 — Graph axes</a:t>
+            </a:r>
+          </a:p>
+          <a:p>
+            <a:pPr algn="l">
+              <a:spcBef>
+                <a:spcPts val="100"/>
+              </a:spcBef>
+            </a:pPr>
+            <a:endParaRPr sz="1300" b="1" dirty="0">
+              <a:solidFill>
+                <a:srgbClr val="FFD700"/>
+              </a:solidFill>
+            </a:endParaRPr>
+          </a:p>
+          <a:p>
+            <a:pPr algn="l">
+              <a:spcBef>
+                <a:spcPts val="100"/>
+              </a:spcBef>
+            </a:pPr>
+            <a:r>
+              <a:rPr sz="1300" b="0" dirty="0">
                 <a:solidFill>
                   <a:srgbClr val="FFFFFF"/>
                 </a:solidFill>
               </a:rPr>
-              <a:t/>
+              <a:t>Slide 5 x-axis:  </a:t>
+            </a:r>
+            <a:r>
+              <a:rPr sz="1300" b="0" dirty="0" err="1">
+                <a:solidFill>
+                  <a:srgbClr val="FFFFFF"/>
+                </a:solidFill>
+              </a:rPr>
+              <a:t>E_beam</a:t>
+            </a:r>
+            <a:r>
+              <a:rPr sz="1300" b="0" dirty="0">
+                <a:solidFill>
+                  <a:srgbClr val="FFFFFF"/>
+                </a:solidFill>
+              </a:rPr>
+              <a:t> (GeV)</a:t>
             </a:r>
           </a:p>
           <a:p>
@@ -4265,12 +4534,52 @@
               </a:spcBef>
             </a:pPr>
             <a:r>
-              <a:rPr sz="1300" b="0">
+              <a:rPr sz="1300" b="0" dirty="0">
                 <a:solidFill>
                   <a:srgbClr val="FFFFFF"/>
                 </a:solidFill>
               </a:rPr>
-              <a:t>r = 1.0  →  perfect reconstruction</a:t>
+              <a:t>Slide 5 y-axis:  mean(</a:t>
+            </a:r>
+            <a:r>
+              <a:rPr sz="1300" b="0" dirty="0" err="1">
+                <a:solidFill>
+                  <a:srgbClr val="FFFFFF"/>
+                </a:solidFill>
+              </a:rPr>
+              <a:t>E_sub</a:t>
+            </a:r>
+            <a:r>
+              <a:rPr lang="en-US" sz="1300" dirty="0" err="1">
+                <a:solidFill>
+                  <a:srgbClr val="FFFFFF"/>
+                </a:solidFill>
+              </a:rPr>
+              <a:t>detector</a:t>
+            </a:r>
+            <a:r>
+              <a:rPr sz="1300" b="0" dirty="0">
+                <a:solidFill>
+                  <a:srgbClr val="FFFFFF"/>
+                </a:solidFill>
+              </a:rPr>
+              <a:t> / </a:t>
+            </a:r>
+            <a:r>
+              <a:rPr sz="1300" b="0" dirty="0" err="1">
+                <a:solidFill>
+                  <a:srgbClr val="FFFFFF"/>
+                </a:solidFill>
+              </a:rPr>
+              <a:t>E_beam</a:t>
+            </a:r>
+            <a:r>
+              <a:rPr sz="1300" b="0" dirty="0">
+                <a:solidFill>
+                  <a:srgbClr val="FFFFFF"/>
+                </a:solidFill>
+              </a:rPr>
+              <a:t>)  per beam energy</a:t>
             </a:r>
           </a:p>
           <a:p>
@@ -4280,12 +4589,44 @@
               </a:spcBef>
             </a:pPr>
             <a:r>
-              <a:rPr sz="1300" b="0">
+              <a:rPr sz="1300" b="0" dirty="0">
                 <a:solidFill>
                   <a:srgbClr val="FFFFFF"/>
                 </a:solidFill>
               </a:rPr>
-              <a:t>r &gt; 1.0  →  overestimated</a:t>
+              <a:t>Slide 6 x-axis:  r = </a:t>
+            </a:r>
+            <a:r>
+              <a:rPr sz="1300" b="0" dirty="0" err="1">
+                <a:solidFill>
+                  <a:srgbClr val="FFFFFF"/>
+                </a:solidFill>
+              </a:rPr>
+              <a:t>E_rec</a:t>
+            </a:r>
+            <a:r>
+              <a:rPr sz="1300" b="0" dirty="0">
+                <a:solidFill>
+                  <a:srgbClr val="FFFFFF"/>
+                </a:solidFill>
+              </a:rPr>
+              <a:t> / </a:t>
+            </a:r>
+            <a:r>
+              <a:rPr sz="1300" b="0" dirty="0" err="1">
+                <a:solidFill>
+                  <a:srgbClr val="FFFFFF"/>
+                </a:solidFill>
+              </a:rPr>
+              <a:t>E_beam</a:t>
+            </a:r>
+            <a:r>
+              <a:rPr sz="1300" b="0" dirty="0">
+                <a:solidFill>
+                  <a:srgbClr val="FFFFFF"/>
+                </a:solidFill>
+              </a:rPr>
+              <a:t>  (single energy)</a:t>
             </a:r>
           </a:p>
           <a:p>
@@ -4295,12 +4636,12 @@
               </a:spcBef>
             </a:pPr>
             <a:r>
-              <a:rPr sz="1300" b="0">
+              <a:rPr sz="1300" b="0" dirty="0">
                 <a:solidFill>
                   <a:srgbClr val="FFFFFF"/>
                 </a:solidFill>
               </a:rPr>
-              <a:t>r &lt; 1.0  →  underestimated</a:t>
+              <a:t>Slide 6 y-axis:  event count</a:t>
             </a:r>
           </a:p>
           <a:p>
@@ -4310,12 +4651,28 @@
               </a:spcBef>
             </a:pPr>
             <a:r>
-              <a:rPr sz="1300" b="0">
+              <a:rPr sz="1300" b="0" dirty="0">
                 <a:solidFill>
                   <a:srgbClr val="FFFFFF"/>
                 </a:solidFill>
               </a:rPr>
-              <a:t/>
+              <a:t>Slides 7-8 x:    </a:t>
+            </a:r>
+            <a:r>
+              <a:rPr sz="1300" b="0" dirty="0" err="1">
+                <a:solidFill>
+                  <a:srgbClr val="FFFFFF"/>
+                </a:solidFill>
+              </a:rPr>
+              <a:t>E_beam</a:t>
+            </a:r>
+            <a:r>
+              <a:rPr sz="1300" b="0" dirty="0">
+                <a:solidFill>
+                  <a:srgbClr val="FFFFFF"/>
+                </a:solidFill>
+              </a:rPr>
+              <a:t> (GeV)</a:t>
             </a:r>
           </a:p>
           <a:p>
@@ -4325,232 +4682,7 @@
               </a:spcBef>
             </a:pPr>
             <a:r>
-              <a:rPr sz="1300" b="1">
-                <a:solidFill>
-                  <a:srgbClr val="FFD700"/>
-                </a:solidFill>
-              </a:rPr>
-              <a:t>Step 4 — Histogram &amp; DCB fit</a:t>
-            </a:r>
-          </a:p>
-          <a:p>
-            <a:pPr algn="l">
-              <a:spcBef>
-                <a:spcPts val="100"/>
-              </a:spcBef>
-            </a:pPr>
-            <a:r>
-              <a:rPr sz="1300" b="0">
-                <a:solidFill>
-                  <a:srgbClr val="FFFFFF"/>
-                </a:solidFill>
-              </a:rPr>
-              <a:t>Collect r for all events at one beam energy.</a:t>
-            </a:r>
-          </a:p>
-          <a:p>
-            <a:pPr algn="l">
-              <a:spcBef>
-                <a:spcPts val="100"/>
-              </a:spcBef>
-            </a:pPr>
-            <a:r>
-              <a:rPr sz="1300" b="0">
-                <a:solidFill>
-                  <a:srgbClr val="FFFFFF"/>
-                </a:solidFill>
-              </a:rPr>
-              <a:t>Fit with Double Crystal Ball (bell curve with power-law tails).</a:t>
-            </a:r>
-          </a:p>
-          <a:p>
-            <a:pPr algn="l">
-              <a:spcBef>
-                <a:spcPts val="100"/>
-              </a:spcBef>
-            </a:pPr>
-            <a:r>
-              <a:rPr sz="1300" b="0">
-                <a:solidFill>
-                  <a:srgbClr val="D0E8F5"/>
-                </a:solidFill>
-              </a:rPr>
-              <a:t>Extract two numbers:</a:t>
-            </a:r>
-          </a:p>
-          <a:p>
-            <a:pPr algn="l">
-              <a:spcBef>
-                <a:spcPts val="100"/>
-              </a:spcBef>
-            </a:pPr>
-            <a:r>
-              <a:rPr sz="1300" b="0">
-                <a:solidFill>
-                  <a:srgbClr val="FFFFFF"/>
-                </a:solidFill>
-              </a:rPr>
-              <a:t/>
-            </a:r>
-          </a:p>
-          <a:p>
-            <a:pPr algn="l">
-              <a:spcBef>
-                <a:spcPts val="100"/>
-              </a:spcBef>
-            </a:pPr>
-            <a:r>
-              <a:rPr sz="1300" b="0">
-                <a:solidFill>
-                  <a:srgbClr val="5CD65C"/>
-                </a:solidFill>
-              </a:rPr>
-              <a:t>  μ  (mu)    =  mean of fit  →  bias</a:t>
-            </a:r>
-          </a:p>
-          <a:p>
-            <a:pPr algn="l">
-              <a:spcBef>
-                <a:spcPts val="100"/>
-              </a:spcBef>
-            </a:pPr>
-            <a:r>
-              <a:rPr sz="1300" b="0">
-                <a:solidFill>
-                  <a:srgbClr val="5CD65C"/>
-                </a:solidFill>
-              </a:rPr>
-              <a:t>  σ  (sigma) =  width of fit →  resolution</a:t>
-            </a:r>
-          </a:p>
-          <a:p>
-            <a:pPr algn="l">
-              <a:spcBef>
-                <a:spcPts val="100"/>
-              </a:spcBef>
-            </a:pPr>
-            <a:r>
-              <a:rPr sz="1300" b="0">
-                <a:solidFill>
-                  <a:srgbClr val="FFFFFF"/>
-                </a:solidFill>
-              </a:rPr>
-              <a:t/>
-            </a:r>
-          </a:p>
-          <a:p>
-            <a:pPr algn="l">
-              <a:spcBef>
-                <a:spcPts val="100"/>
-              </a:spcBef>
-            </a:pPr>
-            <a:r>
-              <a:rPr sz="1300" b="1">
-                <a:solidFill>
-                  <a:srgbClr val="FFD700"/>
-                </a:solidFill>
-              </a:rPr>
-              <a:t>Step 5 — Graph axes</a:t>
-            </a:r>
-          </a:p>
-          <a:p>
-            <a:pPr algn="l">
-              <a:spcBef>
-                <a:spcPts val="100"/>
-              </a:spcBef>
-            </a:pPr>
-            <a:r>
-              <a:rPr sz="1300" b="0">
-                <a:solidFill>
-                  <a:srgbClr val="FFFFFF"/>
-                </a:solidFill>
-              </a:rPr>
-              <a:t/>
-            </a:r>
-          </a:p>
-          <a:p>
-            <a:pPr algn="l">
-              <a:spcBef>
-                <a:spcPts val="100"/>
-              </a:spcBef>
-            </a:pPr>
-            <a:r>
-              <a:rPr sz="1300" b="0">
-                <a:solidFill>
-                  <a:srgbClr val="FFFFFF"/>
-                </a:solidFill>
-              </a:rPr>
-              <a:t>Slide 5 x-axis:  E_beam (GeV)</a:t>
-            </a:r>
-          </a:p>
-          <a:p>
-            <a:pPr algn="l">
-              <a:spcBef>
-                <a:spcPts val="100"/>
-              </a:spcBef>
-            </a:pPr>
-            <a:r>
-              <a:rPr sz="1300" b="0">
-                <a:solidFill>
-                  <a:srgbClr val="FFFFFF"/>
-                </a:solidFill>
-              </a:rPr>
-              <a:t>Slide 5 y-axis:  mean(E_sub / E_beam)  per beam energy</a:t>
-            </a:r>
-          </a:p>
-          <a:p>
-            <a:pPr algn="l">
-              <a:spcBef>
-                <a:spcPts val="100"/>
-              </a:spcBef>
-            </a:pPr>
-            <a:r>
-              <a:rPr sz="1300" b="0">
-                <a:solidFill>
-                  <a:srgbClr val="FFFFFF"/>
-                </a:solidFill>
-              </a:rPr>
-              <a:t>Slide 6 x-axis:  r = E_rec / E_beam  (single energy)</a:t>
-            </a:r>
-          </a:p>
-          <a:p>
-            <a:pPr algn="l">
-              <a:spcBef>
-                <a:spcPts val="100"/>
-              </a:spcBef>
-            </a:pPr>
-            <a:r>
-              <a:rPr sz="1300" b="0">
-                <a:solidFill>
-                  <a:srgbClr val="FFFFFF"/>
-                </a:solidFill>
-              </a:rPr>
-              <a:t>Slide 6 y-axis:  event count</a:t>
-            </a:r>
-          </a:p>
-          <a:p>
-            <a:pPr algn="l">
-              <a:spcBef>
-                <a:spcPts val="100"/>
-              </a:spcBef>
-            </a:pPr>
-            <a:r>
-              <a:rPr sz="1300" b="0">
-                <a:solidFill>
-                  <a:srgbClr val="FFFFFF"/>
-                </a:solidFill>
-              </a:rPr>
-              <a:t>Slides 7-8 x:    E_beam (GeV)</a:t>
-            </a:r>
-          </a:p>
-          <a:p>
-            <a:pPr algn="l">
-              <a:spcBef>
-                <a:spcPts val="100"/>
-              </a:spcBef>
-            </a:pPr>
-            <a:r>
-              <a:rPr sz="1300" b="0">
+              <a:rPr sz="1300" b="0" dirty="0">
                 <a:solidFill>
                   <a:srgbClr val="FFFFFF"/>
                 </a:solidFill>
@@ -4569,7 +4701,7 @@
 </file>
 
 <file path=ppt/slides/slide3.xml><?xml version="1.0" encoding="utf-8"?>
-<p:sld xmlns:a="http://schemas.openxmlformats.org/drawingml/2006/main" xmlns:p="http://schemas.openxmlformats.org/presentationml/2006/main" xmlns:r="http://schemas.openxmlformats.org/officeDocument/2006/relationships">
+<p:sld xmlns:a="http://schemas.openxmlformats.org/drawingml/2006/main" xmlns:r="http://schemas.openxmlformats.org/officeDocument/2006/relationships" xmlns:p="http://schemas.openxmlformats.org/presentationml/2006/main">
   <p:cSld>
     <p:bg>
       <p:bgPr>
@@ -4585,7 +4717,14 @@
         <p:cNvGrpSpPr/>
         <p:nvPr/>
       </p:nvGrpSpPr>
-      <p:grpSpPr/>
+      <p:grpSpPr>
+        <a:xfrm>
+          <a:off x="0" y="0"/>
+          <a:ext cx="0" cy="0"/>
+          <a:chOff x="0" y="0"/>
+          <a:chExt cx="0" cy="0"/>
+        </a:xfrm>
+      </p:grpSpPr>
       <p:sp>
         <p:nvSpPr>
           <p:cNvPr id="2" name="Rectangle 1"/>
@@ -4626,6 +4765,7 @@
           <a:lstStyle/>
           <a:p>
             <a:pPr algn="ctr"/>
+            <a:endParaRPr/>
           </a:p>
         </p:txBody>
       </p:sp>
@@ -4669,6 +4809,7 @@
           <a:lstStyle/>
           <a:p>
             <a:pPr algn="ctr"/>
+            <a:endParaRPr/>
           </a:p>
         </p:txBody>
       </p:sp>
@@ -4776,6 +4917,7 @@
           <a:lstStyle/>
           <a:p>
             <a:pPr algn="ctr"/>
+            <a:endParaRPr/>
           </a:p>
         </p:txBody>
       </p:sp>
@@ -4836,13 +4978,40 @@
                 <a:spcPts val="300"/>
               </a:spcBef>
             </a:pPr>
+            <a:endParaRPr sz="1400" b="0">
+              <a:solidFill>
+                <a:srgbClr val="FFFFFF"/>
+              </a:solidFill>
+            </a:endParaRPr>
+          </a:p>
+          <a:p>
+            <a:pPr algn="l">
+              <a:spcBef>
+                <a:spcPts val="300"/>
+              </a:spcBef>
+            </a:pPr>
+            <a:r>
+              <a:rPr sz="1400" b="1">
+                <a:solidFill>
+                  <a:srgbClr val="FFD700"/>
+                </a:solidFill>
+              </a:rPr>
+              <a:t>Why regression?</a:t>
+            </a:r>
+          </a:p>
+          <a:p>
+            <a:pPr algn="l">
+              <a:spcBef>
+                <a:spcPts val="300"/>
+              </a:spcBef>
+            </a:pPr>
             <a:r>
               <a:rPr sz="1400" b="0">
                 <a:solidFill>
                   <a:srgbClr val="FFFFFF"/>
                 </a:solidFill>
               </a:rPr>
-              <a:t/>
+              <a:t>Raw signals are not equal to energy — there is leakage, dead material, and non-linearity. Regression learns the correction from simulation.</a:t>
             </a:r>
           </a:p>
           <a:p>
@@ -4851,44 +5020,11 @@
                 <a:spcPts val="300"/>
               </a:spcBef>
             </a:pPr>
-            <a:r>
-              <a:rPr sz="1400" b="1">
-                <a:solidFill>
-                  <a:srgbClr val="FFD700"/>
-                </a:solidFill>
-              </a:rPr>
-              <a:t>Why regression?</a:t>
-            </a:r>
-          </a:p>
-          <a:p>
-            <a:pPr algn="l">
-              <a:spcBef>
-                <a:spcPts val="300"/>
-              </a:spcBef>
-            </a:pPr>
-            <a:r>
-              <a:rPr sz="1400" b="0">
-                <a:solidFill>
-                  <a:srgbClr val="FFFFFF"/>
-                </a:solidFill>
-              </a:rPr>
-              <a:t>Raw signals are not equal to energy — there is leakage, dead material, and non-linearity. Regression learns the correction from simulation.</a:t>
-            </a:r>
-          </a:p>
-          <a:p>
-            <a:pPr algn="l">
-              <a:spcBef>
-                <a:spcPts val="300"/>
-              </a:spcBef>
-            </a:pPr>
-            <a:r>
-              <a:rPr sz="1400" b="0">
-                <a:solidFill>
-                  <a:srgbClr val="FFFFFF"/>
-                </a:solidFill>
-              </a:rPr>
-              <a:t/>
-            </a:r>
+            <a:endParaRPr sz="1400" b="0">
+              <a:solidFill>
+                <a:srgbClr val="FFFFFF"/>
+              </a:solidFill>
+            </a:endParaRPr>
           </a:p>
           <a:p>
             <a:pPr algn="l">
@@ -4979,14 +5115,11 @@
                 <a:spcPts val="300"/>
               </a:spcBef>
             </a:pPr>
-            <a:r>
-              <a:rPr sz="1400" b="0">
-                <a:solidFill>
-                  <a:srgbClr val="FFFFFF"/>
-                </a:solidFill>
-              </a:rPr>
-              <a:t/>
-            </a:r>
+            <a:endParaRPr sz="1400" b="0">
+              <a:solidFill>
+                <a:srgbClr val="FFFFFF"/>
+              </a:solidFill>
+            </a:endParaRPr>
           </a:p>
           <a:p>
             <a:pPr algn="l">
@@ -5129,13 +5262,25 @@
                 <a:spcPts val="200"/>
               </a:spcBef>
             </a:pPr>
+            <a:endParaRPr sz="1300" b="1">
+              <a:solidFill>
+                <a:srgbClr val="FFD700"/>
+              </a:solidFill>
+            </a:endParaRPr>
+          </a:p>
+          <a:p>
+            <a:pPr algn="l">
+              <a:spcBef>
+                <a:spcPts val="200"/>
+              </a:spcBef>
+            </a:pPr>
             <a:r>
               <a:rPr sz="1300" b="0">
                 <a:solidFill>
                   <a:srgbClr val="FFFFFF"/>
                 </a:solidFill>
               </a:rPr>
-              <a:t/>
+              <a:t>m0 w0 — Linear, Equal</a:t>
             </a:r>
           </a:p>
           <a:p>
@@ -5150,7 +5295,7 @@
                   <a:srgbClr val="FFFFFF"/>
                 </a:solidFill>
               </a:rPr>
-              <a:t>m0 w0 — Linear, Equal</a:t>
+              <a:t>m1 w0 — Ratio,  Equal</a:t>
             </a:r>
           </a:p>
           <a:p>
@@ -5165,7 +5310,7 @@
                   <a:srgbClr val="FFFFFF"/>
                 </a:solidFill>
               </a:rPr>
-              <a:t>m1 w0 — Ratio,  Equal</a:t>
+              <a:t>m2 w0 — Quadratic, Equal</a:t>
             </a:r>
           </a:p>
           <a:p>
@@ -5180,7 +5325,7 @@
                   <a:srgbClr val="FFFFFF"/>
                 </a:solidFill>
               </a:rPr>
-              <a:t>m2 w0 — Quadratic, Equal</a:t>
+              <a:t>m0 w1 — Linear, √E-weighted</a:t>
             </a:r>
           </a:p>
           <a:p>
@@ -5195,7 +5340,7 @@
                   <a:srgbClr val="FFFFFF"/>
                 </a:solidFill>
               </a:rPr>
-              <a:t>m0 w1 — Linear, √E-weighted</a:t>
+              <a:t>m1 w1 — Ratio,  √E-weighted</a:t>
             </a:r>
           </a:p>
           <a:p>
@@ -5210,7 +5355,7 @@
                   <a:srgbClr val="FFFFFF"/>
                 </a:solidFill>
               </a:rPr>
-              <a:t>m1 w1 — Ratio,  √E-weighted</a:t>
+              <a:t>m2 w1 — Quadratic, √E-weighted</a:t>
             </a:r>
           </a:p>
           <a:p>
@@ -5219,13 +5364,25 @@
                 <a:spcPts val="200"/>
               </a:spcBef>
             </a:pPr>
+            <a:endParaRPr sz="1300" b="0">
+              <a:solidFill>
+                <a:srgbClr val="FFFFFF"/>
+              </a:solidFill>
+            </a:endParaRPr>
+          </a:p>
+          <a:p>
+            <a:pPr algn="l">
+              <a:spcBef>
+                <a:spcPts val="200"/>
+              </a:spcBef>
+            </a:pPr>
             <a:r>
               <a:rPr sz="1300" b="0">
                 <a:solidFill>
-                  <a:srgbClr val="FFFFFF"/>
-                </a:solidFill>
-              </a:rPr>
-              <a:t>m2 w1 — Quadratic, √E-weighted</a:t>
+                  <a:srgbClr val="D0E8F5"/>
+                </a:solidFill>
+              </a:rPr>
+              <a:t>All six appear on resolution</a:t>
             </a:r>
           </a:p>
           <a:p>
@@ -5237,10 +5394,10 @@
             <a:r>
               <a:rPr sz="1300" b="0">
                 <a:solidFill>
-                  <a:srgbClr val="FFFFFF"/>
-                </a:solidFill>
-              </a:rPr>
-              <a:t/>
+                  <a:srgbClr val="D0E8F5"/>
+                </a:solidFill>
+              </a:rPr>
+              <a:t>and bias plots. Compare them</a:t>
             </a:r>
           </a:p>
           <a:p>
@@ -5255,7 +5412,7 @@
                   <a:srgbClr val="D0E8F5"/>
                 </a:solidFill>
               </a:rPr>
-              <a:t>All six appear on resolution</a:t>
+              <a:t>to find best-performing method.</a:t>
             </a:r>
           </a:p>
           <a:p>
@@ -5264,44 +5421,11 @@
                 <a:spcPts val="200"/>
               </a:spcBef>
             </a:pPr>
-            <a:r>
-              <a:rPr sz="1300" b="0">
-                <a:solidFill>
-                  <a:srgbClr val="D0E8F5"/>
-                </a:solidFill>
-              </a:rPr>
-              <a:t>and bias plots. Compare them</a:t>
-            </a:r>
-          </a:p>
-          <a:p>
-            <a:pPr algn="l">
-              <a:spcBef>
-                <a:spcPts val="200"/>
-              </a:spcBef>
-            </a:pPr>
-            <a:r>
-              <a:rPr sz="1300" b="0">
-                <a:solidFill>
-                  <a:srgbClr val="D0E8F5"/>
-                </a:solidFill>
-              </a:rPr>
-              <a:t>to find best-performing method.</a:t>
-            </a:r>
-          </a:p>
-          <a:p>
-            <a:pPr algn="l">
-              <a:spcBef>
-                <a:spcPts val="200"/>
-              </a:spcBef>
-            </a:pPr>
-            <a:r>
-              <a:rPr sz="1300" b="0">
-                <a:solidFill>
-                  <a:srgbClr val="FFFFFF"/>
-                </a:solidFill>
-              </a:rPr>
-              <a:t/>
-            </a:r>
+            <a:endParaRPr sz="1300" b="0">
+              <a:solidFill>
+                <a:srgbClr val="D0E8F5"/>
+              </a:solidFill>
+            </a:endParaRPr>
           </a:p>
           <a:p>
             <a:pPr algn="l">
@@ -5389,7 +5513,7 @@
 </file>
 
 <file path=ppt/slides/slide4.xml><?xml version="1.0" encoding="utf-8"?>
-<p:sld xmlns:a="http://schemas.openxmlformats.org/drawingml/2006/main" xmlns:p="http://schemas.openxmlformats.org/presentationml/2006/main" xmlns:r="http://schemas.openxmlformats.org/officeDocument/2006/relationships">
+<p:sld xmlns:a="http://schemas.openxmlformats.org/drawingml/2006/main" xmlns:r="http://schemas.openxmlformats.org/officeDocument/2006/relationships" xmlns:p="http://schemas.openxmlformats.org/presentationml/2006/main">
   <p:cSld>
     <p:bg>
       <p:bgPr>
@@ -5405,7 +5529,14 @@
         <p:cNvGrpSpPr/>
         <p:nvPr/>
       </p:nvGrpSpPr>
-      <p:grpSpPr/>
+      <p:grpSpPr>
+        <a:xfrm>
+          <a:off x="0" y="0"/>
+          <a:ext cx="0" cy="0"/>
+          <a:chOff x="0" y="0"/>
+          <a:chExt cx="0" cy="0"/>
+        </a:xfrm>
+      </p:grpSpPr>
       <p:sp>
         <p:nvSpPr>
           <p:cNvPr id="2" name="Rectangle 1"/>
@@ -5446,6 +5577,7 @@
           <a:lstStyle/>
           <a:p>
             <a:pPr algn="ctr"/>
+            <a:endParaRPr/>
           </a:p>
         </p:txBody>
       </p:sp>
@@ -5489,6 +5621,7 @@
           <a:lstStyle/>
           <a:p>
             <a:pPr algn="ctr"/>
+            <a:endParaRPr/>
           </a:p>
         </p:txBody>
       </p:sp>
@@ -5596,6 +5729,7 @@
           <a:lstStyle/>
           <a:p>
             <a:pPr algn="ctr"/>
+            <a:endParaRPr/>
           </a:p>
         </p:txBody>
       </p:sp>
@@ -5672,13 +5806,40 @@
                 <a:spcPts val="200"/>
               </a:spcBef>
             </a:pPr>
+            <a:endParaRPr sz="1300" b="1">
+              <a:solidFill>
+                <a:srgbClr val="FFD700"/>
+              </a:solidFill>
+            </a:endParaRPr>
+          </a:p>
+          <a:p>
+            <a:pPr algn="l">
+              <a:spcBef>
+                <a:spcPts val="200"/>
+              </a:spcBef>
+            </a:pPr>
             <a:r>
               <a:rPr sz="1300" b="0">
                 <a:solidFill>
+                  <a:srgbClr val="D0E8F5"/>
+                </a:solidFill>
+              </a:rPr>
+              <a:t>x-axis:  E_beam (GeV)</a:t>
+            </a:r>
+          </a:p>
+          <a:p>
+            <a:pPr algn="l">
+              <a:spcBef>
+                <a:spcPts val="200"/>
+              </a:spcBef>
+            </a:pPr>
+            <a:r>
+              <a:rPr sz="1300" b="0">
+                <a:solidFill>
                   <a:srgbClr val="FFFFFF"/>
                 </a:solidFill>
               </a:rPr>
-              <a:t/>
+              <a:t>True simulated beam energy.</a:t>
             </a:r>
           </a:p>
           <a:p>
@@ -5687,13 +5848,25 @@
                 <a:spcPts val="200"/>
               </a:spcBef>
             </a:pPr>
+            <a:endParaRPr sz="1300" b="0">
+              <a:solidFill>
+                <a:srgbClr val="FFFFFF"/>
+              </a:solidFill>
+            </a:endParaRPr>
+          </a:p>
+          <a:p>
+            <a:pPr algn="l">
+              <a:spcBef>
+                <a:spcPts val="200"/>
+              </a:spcBef>
+            </a:pPr>
             <a:r>
               <a:rPr sz="1300" b="0">
                 <a:solidFill>
                   <a:srgbClr val="D0E8F5"/>
                 </a:solidFill>
               </a:rPr>
-              <a:t>x-axis:  E_beam (GeV)</a:t>
+              <a:t>y-axis:  E_sub / E_beam</a:t>
             </a:r>
           </a:p>
           <a:p>
@@ -5708,7 +5881,7 @@
                   <a:srgbClr val="FFFFFF"/>
                 </a:solidFill>
               </a:rPr>
-              <a:t>True simulated beam energy.</a:t>
+              <a:t>Fraction of beam energy seen</a:t>
             </a:r>
           </a:p>
           <a:p>
@@ -5723,7 +5896,7 @@
                   <a:srgbClr val="FFFFFF"/>
                 </a:solidFill>
               </a:rPr>
-              <a:t/>
+              <a:t>by ECAL, HCAL, or both.</a:t>
             </a:r>
           </a:p>
           <a:p>
@@ -5735,10 +5908,10 @@
             <a:r>
               <a:rPr sz="1300" b="0">
                 <a:solidFill>
-                  <a:srgbClr val="D0E8F5"/>
-                </a:solidFill>
-              </a:rPr>
-              <a:t>y-axis:  E_sub / E_beam</a:t>
+                  <a:srgbClr val="FFFFFF"/>
+                </a:solidFill>
+              </a:rPr>
+              <a:t>Averaged over all events at</a:t>
             </a:r>
           </a:p>
           <a:p>
@@ -5753,7 +5926,7 @@
                   <a:srgbClr val="FFFFFF"/>
                 </a:solidFill>
               </a:rPr>
-              <a:t>Fraction of beam energy seen</a:t>
+              <a:t>that beam energy.</a:t>
             </a:r>
           </a:p>
           <a:p>
@@ -5762,13 +5935,52 @@
                 <a:spcPts val="200"/>
               </a:spcBef>
             </a:pPr>
+            <a:endParaRPr sz="1300" b="0">
+              <a:solidFill>
+                <a:srgbClr val="FFFFFF"/>
+              </a:solidFill>
+            </a:endParaRPr>
+          </a:p>
+          <a:p>
+            <a:pPr algn="l">
+              <a:spcBef>
+                <a:spcPts val="200"/>
+              </a:spcBef>
+            </a:pPr>
+            <a:r>
+              <a:rPr sz="1300" b="1">
+                <a:solidFill>
+                  <a:srgbClr val="FFD700"/>
+                </a:solidFill>
+              </a:rPr>
+              <a:t>Observations</a:t>
+            </a:r>
+          </a:p>
+          <a:p>
+            <a:pPr algn="l">
+              <a:spcBef>
+                <a:spcPts val="200"/>
+              </a:spcBef>
+            </a:pPr>
+            <a:endParaRPr sz="1300" b="1">
+              <a:solidFill>
+                <a:srgbClr val="FFD700"/>
+              </a:solidFill>
+            </a:endParaRPr>
+          </a:p>
+          <a:p>
+            <a:pPr algn="l">
+              <a:spcBef>
+                <a:spcPts val="200"/>
+              </a:spcBef>
+            </a:pPr>
             <a:r>
               <a:rPr sz="1300" b="0">
                 <a:solidFill>
                   <a:srgbClr val="FFFFFF"/>
                 </a:solidFill>
               </a:rPr>
-              <a:t>by ECAL, HCAL, or both.</a:t>
+              <a:t>Gamma ECAL: 0.5 → 0.15</a:t>
             </a:r>
           </a:p>
           <a:p>
@@ -5780,10 +5992,10 @@
             <a:r>
               <a:rPr sz="1300" b="0">
                 <a:solidFill>
-                  <a:srgbClr val="FFFFFF"/>
-                </a:solidFill>
-              </a:rPr>
-              <a:t>Averaged over all events at</a:t>
+                  <a:srgbClr val="CCCCCC"/>
+                </a:solidFill>
+              </a:rPr>
+              <a:t>Falls with energy (saturation).</a:t>
             </a:r>
           </a:p>
           <a:p>
@@ -5795,10 +6007,10 @@
             <a:r>
               <a:rPr sz="1300" b="0">
                 <a:solidFill>
-                  <a:srgbClr val="FFFFFF"/>
-                </a:solidFill>
-              </a:rPr>
-              <a:t>that beam energy.</a:t>
+                  <a:srgbClr val="CCCCCC"/>
+                </a:solidFill>
+              </a:rPr>
+              <a:t>HCAL: tiny (10⁻³ scale).</a:t>
             </a:r>
           </a:p>
           <a:p>
@@ -5807,104 +6019,11 @@
                 <a:spcPts val="200"/>
               </a:spcBef>
             </a:pPr>
-            <a:r>
-              <a:rPr sz="1300" b="0">
-                <a:solidFill>
-                  <a:srgbClr val="FFFFFF"/>
-                </a:solidFill>
-              </a:rPr>
-              <a:t/>
-            </a:r>
-          </a:p>
-          <a:p>
-            <a:pPr algn="l">
-              <a:spcBef>
-                <a:spcPts val="200"/>
-              </a:spcBef>
-            </a:pPr>
-            <a:r>
-              <a:rPr sz="1300" b="1">
-                <a:solidFill>
-                  <a:srgbClr val="FFD700"/>
-                </a:solidFill>
-              </a:rPr>
-              <a:t>Observations</a:t>
-            </a:r>
-          </a:p>
-          <a:p>
-            <a:pPr algn="l">
-              <a:spcBef>
-                <a:spcPts val="200"/>
-              </a:spcBef>
-            </a:pPr>
-            <a:r>
-              <a:rPr sz="1300" b="0">
-                <a:solidFill>
-                  <a:srgbClr val="FFFFFF"/>
-                </a:solidFill>
-              </a:rPr>
-              <a:t/>
-            </a:r>
-          </a:p>
-          <a:p>
-            <a:pPr algn="l">
-              <a:spcBef>
-                <a:spcPts val="200"/>
-              </a:spcBef>
-            </a:pPr>
-            <a:r>
-              <a:rPr sz="1300" b="0">
-                <a:solidFill>
-                  <a:srgbClr val="FFFFFF"/>
-                </a:solidFill>
-              </a:rPr>
-              <a:t>Gamma ECAL: 0.5 → 0.15</a:t>
-            </a:r>
-          </a:p>
-          <a:p>
-            <a:pPr algn="l">
-              <a:spcBef>
-                <a:spcPts val="200"/>
-              </a:spcBef>
-            </a:pPr>
-            <a:r>
-              <a:rPr sz="1300" b="0">
-                <a:solidFill>
-                  <a:srgbClr val="CCCCCC"/>
-                </a:solidFill>
-              </a:rPr>
-              <a:t>Falls with energy (saturation).</a:t>
-            </a:r>
-          </a:p>
-          <a:p>
-            <a:pPr algn="l">
-              <a:spcBef>
-                <a:spcPts val="200"/>
-              </a:spcBef>
-            </a:pPr>
-            <a:r>
-              <a:rPr sz="1300" b="0">
-                <a:solidFill>
-                  <a:srgbClr val="CCCCCC"/>
-                </a:solidFill>
-              </a:rPr>
-              <a:t>HCAL: tiny (10⁻³ scale).</a:t>
-            </a:r>
-          </a:p>
-          <a:p>
-            <a:pPr algn="l">
-              <a:spcBef>
-                <a:spcPts val="200"/>
-              </a:spcBef>
-            </a:pPr>
-            <a:r>
-              <a:rPr sz="1300" b="0">
-                <a:solidFill>
-                  <a:srgbClr val="FFFFFF"/>
-                </a:solidFill>
-              </a:rPr>
-              <a:t/>
-            </a:r>
+            <a:endParaRPr sz="1300" b="0">
+              <a:solidFill>
+                <a:srgbClr val="CCCCCC"/>
+              </a:solidFill>
+            </a:endParaRPr>
           </a:p>
           <a:p>
             <a:pPr algn="l">
@@ -5962,7 +6081,7 @@
 </file>
 
 <file path=ppt/slides/slide5.xml><?xml version="1.0" encoding="utf-8"?>
-<p:sld xmlns:a="http://schemas.openxmlformats.org/drawingml/2006/main" xmlns:p="http://schemas.openxmlformats.org/presentationml/2006/main" xmlns:r="http://schemas.openxmlformats.org/officeDocument/2006/relationships">
+<p:sld xmlns:a="http://schemas.openxmlformats.org/drawingml/2006/main" xmlns:r="http://schemas.openxmlformats.org/officeDocument/2006/relationships" xmlns:p="http://schemas.openxmlformats.org/presentationml/2006/main">
   <p:cSld>
     <p:bg>
       <p:bgPr>
@@ -5978,7 +6097,14 @@
         <p:cNvGrpSpPr/>
         <p:nvPr/>
       </p:nvGrpSpPr>
-      <p:grpSpPr/>
+      <p:grpSpPr>
+        <a:xfrm>
+          <a:off x="0" y="0"/>
+          <a:ext cx="0" cy="0"/>
+          <a:chOff x="0" y="0"/>
+          <a:chExt cx="0" cy="0"/>
+        </a:xfrm>
+      </p:grpSpPr>
       <p:sp>
         <p:nvSpPr>
           <p:cNvPr id="2" name="Rectangle 1"/>
@@ -6019,6 +6145,7 @@
           <a:lstStyle/>
           <a:p>
             <a:pPr algn="ctr"/>
+            <a:endParaRPr/>
           </a:p>
         </p:txBody>
       </p:sp>
@@ -6062,6 +6189,7 @@
           <a:lstStyle/>
           <a:p>
             <a:pPr algn="ctr"/>
+            <a:endParaRPr/>
           </a:p>
         </p:txBody>
       </p:sp>
@@ -6169,6 +6297,7 @@
           <a:lstStyle/>
           <a:p>
             <a:pPr algn="ctr"/>
+            <a:endParaRPr/>
           </a:p>
         </p:txBody>
       </p:sp>
@@ -6245,13 +6374,40 @@
                 <a:spcPts val="200"/>
               </a:spcBef>
             </a:pPr>
+            <a:endParaRPr sz="1300" b="1">
+              <a:solidFill>
+                <a:srgbClr val="FFD700"/>
+              </a:solidFill>
+            </a:endParaRPr>
+          </a:p>
+          <a:p>
+            <a:pPr algn="l">
+              <a:spcBef>
+                <a:spcPts val="200"/>
+              </a:spcBef>
+            </a:pPr>
             <a:r>
               <a:rPr sz="1300" b="0">
                 <a:solidFill>
+                  <a:srgbClr val="D0E8F5"/>
+                </a:solidFill>
+              </a:rPr>
+              <a:t>x-axis:  r = E_rec / E_beam</a:t>
+            </a:r>
+          </a:p>
+          <a:p>
+            <a:pPr algn="l">
+              <a:spcBef>
+                <a:spcPts val="200"/>
+              </a:spcBef>
+            </a:pPr>
+            <a:r>
+              <a:rPr sz="1300" b="0">
+                <a:solidFill>
                   <a:srgbClr val="FFFFFF"/>
                 </a:solidFill>
               </a:rPr>
-              <a:t/>
+              <a:t>Reconstructed energy divided by</a:t>
             </a:r>
           </a:p>
           <a:p>
@@ -6263,10 +6419,52 @@
             <a:r>
               <a:rPr sz="1300" b="0">
                 <a:solidFill>
+                  <a:srgbClr val="FFFFFF"/>
+                </a:solidFill>
+              </a:rPr>
+              <a:t>true beam energy, per event.</a:t>
+            </a:r>
+          </a:p>
+          <a:p>
+            <a:pPr algn="l">
+              <a:spcBef>
+                <a:spcPts val="200"/>
+              </a:spcBef>
+            </a:pPr>
+            <a:r>
+              <a:rPr sz="1300" b="0">
+                <a:solidFill>
+                  <a:srgbClr val="FFFFFF"/>
+                </a:solidFill>
+              </a:rPr>
+              <a:t>r = 1.0 is perfect.</a:t>
+            </a:r>
+          </a:p>
+          <a:p>
+            <a:pPr algn="l">
+              <a:spcBef>
+                <a:spcPts val="200"/>
+              </a:spcBef>
+            </a:pPr>
+            <a:endParaRPr sz="1300" b="0">
+              <a:solidFill>
+                <a:srgbClr val="FFFFFF"/>
+              </a:solidFill>
+            </a:endParaRPr>
+          </a:p>
+          <a:p>
+            <a:pPr algn="l">
+              <a:spcBef>
+                <a:spcPts val="200"/>
+              </a:spcBef>
+            </a:pPr>
+            <a:r>
+              <a:rPr sz="1300" b="0">
+                <a:solidFill>
                   <a:srgbClr val="D0E8F5"/>
                 </a:solidFill>
               </a:rPr>
-              <a:t>x-axis:  r = E_rec / E_beam</a:t>
+              <a:t>y-axis:  Counts</a:t>
             </a:r>
           </a:p>
           <a:p>
@@ -6281,7 +6479,7 @@
                   <a:srgbClr val="FFFFFF"/>
                 </a:solidFill>
               </a:rPr>
-              <a:t>Reconstructed energy divided by</a:t>
+              <a:t>How many events fell in each r bin.</a:t>
             </a:r>
           </a:p>
           <a:p>
@@ -6290,13 +6488,40 @@
                 <a:spcPts val="200"/>
               </a:spcBef>
             </a:pPr>
+            <a:endParaRPr sz="1300" b="0">
+              <a:solidFill>
+                <a:srgbClr val="FFFFFF"/>
+              </a:solidFill>
+            </a:endParaRPr>
+          </a:p>
+          <a:p>
+            <a:pPr algn="l">
+              <a:spcBef>
+                <a:spcPts val="200"/>
+              </a:spcBef>
+            </a:pPr>
             <a:r>
               <a:rPr sz="1300" b="0">
                 <a:solidFill>
+                  <a:srgbClr val="D0E8F5"/>
+                </a:solidFill>
+              </a:rPr>
+              <a:t>Red curve:  DCB fit</a:t>
+            </a:r>
+          </a:p>
+          <a:p>
+            <a:pPr algn="l">
+              <a:spcBef>
+                <a:spcPts val="200"/>
+              </a:spcBef>
+            </a:pPr>
+            <a:r>
+              <a:rPr sz="1300" b="0">
+                <a:solidFill>
                   <a:srgbClr val="FFFFFF"/>
                 </a:solidFill>
               </a:rPr>
-              <a:t>true beam energy, per event.</a:t>
+              <a:t>Bell curve with heavier tails.</a:t>
             </a:r>
           </a:p>
           <a:p>
@@ -6311,7 +6536,7 @@
                   <a:srgbClr val="FFFFFF"/>
                 </a:solidFill>
               </a:rPr>
-              <a:t>r = 1.0 is perfect.</a:t>
+              <a:t>Fit extracts μ and σ.</a:t>
             </a:r>
           </a:p>
           <a:p>
@@ -6320,13 +6545,55 @@
                 <a:spcPts val="200"/>
               </a:spcBef>
             </a:pPr>
+            <a:endParaRPr sz="1300" b="0">
+              <a:solidFill>
+                <a:srgbClr val="FFFFFF"/>
+              </a:solidFill>
+            </a:endParaRPr>
+          </a:p>
+          <a:p>
+            <a:pPr algn="l">
+              <a:spcBef>
+                <a:spcPts val="200"/>
+              </a:spcBef>
+            </a:pPr>
+            <a:r>
+              <a:rPr sz="1300" b="1">
+                <a:solidFill>
+                  <a:srgbClr val="FFD700"/>
+                </a:solidFill>
+              </a:rPr>
+              <a:t>Stats box</a:t>
+            </a:r>
+          </a:p>
+          <a:p>
+            <a:pPr algn="l">
+              <a:spcBef>
+                <a:spcPts val="200"/>
+              </a:spcBef>
+            </a:pPr>
             <a:r>
               <a:rPr sz="1300" b="0">
                 <a:solidFill>
+                  <a:srgbClr val="5CD65C"/>
+                </a:solidFill>
+              </a:rPr>
+              <a:t>Mean  = 1.01  →  bias near 0%</a:t>
+            </a:r>
+          </a:p>
+          <a:p>
+            <a:pPr algn="l">
+              <a:spcBef>
+                <a:spcPts val="200"/>
+              </a:spcBef>
+            </a:pPr>
+            <a:r>
+              <a:rPr sz="1300" b="0">
+                <a:solidFill>
                   <a:srgbClr val="FFFFFF"/>
                 </a:solidFill>
               </a:rPr>
-              <a:t/>
+              <a:t>Sigma = 0.15  →  15% resolution</a:t>
             </a:r>
           </a:p>
           <a:p>
@@ -6338,10 +6605,10 @@
             <a:r>
               <a:rPr sz="1300" b="0">
                 <a:solidFill>
-                  <a:srgbClr val="D0E8F5"/>
-                </a:solidFill>
-              </a:rPr>
-              <a:t>y-axis:  Counts</a:t>
+                  <a:srgbClr val="CCCCCC"/>
+                </a:solidFill>
+              </a:rPr>
+              <a:t>                at 1 GeV (expected)</a:t>
             </a:r>
           </a:p>
           <a:p>
@@ -6356,7 +6623,7 @@
                   <a:srgbClr val="FFFFFF"/>
                 </a:solidFill>
               </a:rPr>
-              <a:t>How many events fell in each r bin.</a:t>
+              <a:t>Chi2/NDF = 0.78  →  good fit</a:t>
             </a:r>
           </a:p>
           <a:p>
@@ -6365,164 +6632,11 @@
                 <a:spcPts val="200"/>
               </a:spcBef>
             </a:pPr>
-            <a:r>
-              <a:rPr sz="1300" b="0">
-                <a:solidFill>
-                  <a:srgbClr val="FFFFFF"/>
-                </a:solidFill>
-              </a:rPr>
-              <a:t/>
-            </a:r>
-          </a:p>
-          <a:p>
-            <a:pPr algn="l">
-              <a:spcBef>
-                <a:spcPts val="200"/>
-              </a:spcBef>
-            </a:pPr>
-            <a:r>
-              <a:rPr sz="1300" b="0">
-                <a:solidFill>
-                  <a:srgbClr val="D0E8F5"/>
-                </a:solidFill>
-              </a:rPr>
-              <a:t>Red curve:  DCB fit</a:t>
-            </a:r>
-          </a:p>
-          <a:p>
-            <a:pPr algn="l">
-              <a:spcBef>
-                <a:spcPts val="200"/>
-              </a:spcBef>
-            </a:pPr>
-            <a:r>
-              <a:rPr sz="1300" b="0">
-                <a:solidFill>
-                  <a:srgbClr val="FFFFFF"/>
-                </a:solidFill>
-              </a:rPr>
-              <a:t>Bell curve with heavier tails.</a:t>
-            </a:r>
-          </a:p>
-          <a:p>
-            <a:pPr algn="l">
-              <a:spcBef>
-                <a:spcPts val="200"/>
-              </a:spcBef>
-            </a:pPr>
-            <a:r>
-              <a:rPr sz="1300" b="0">
-                <a:solidFill>
-                  <a:srgbClr val="FFFFFF"/>
-                </a:solidFill>
-              </a:rPr>
-              <a:t>Fit extracts μ and σ.</a:t>
-            </a:r>
-          </a:p>
-          <a:p>
-            <a:pPr algn="l">
-              <a:spcBef>
-                <a:spcPts val="200"/>
-              </a:spcBef>
-            </a:pPr>
-            <a:r>
-              <a:rPr sz="1300" b="0">
-                <a:solidFill>
-                  <a:srgbClr val="FFFFFF"/>
-                </a:solidFill>
-              </a:rPr>
-              <a:t/>
-            </a:r>
-          </a:p>
-          <a:p>
-            <a:pPr algn="l">
-              <a:spcBef>
-                <a:spcPts val="200"/>
-              </a:spcBef>
-            </a:pPr>
-            <a:r>
-              <a:rPr sz="1300" b="1">
-                <a:solidFill>
-                  <a:srgbClr val="FFD700"/>
-                </a:solidFill>
-              </a:rPr>
-              <a:t>Stats box</a:t>
-            </a:r>
-          </a:p>
-          <a:p>
-            <a:pPr algn="l">
-              <a:spcBef>
-                <a:spcPts val="200"/>
-              </a:spcBef>
-            </a:pPr>
-            <a:r>
-              <a:rPr sz="1300" b="0">
-                <a:solidFill>
-                  <a:srgbClr val="5CD65C"/>
-                </a:solidFill>
-              </a:rPr>
-              <a:t>Mean  = 1.01  →  bias near 0%</a:t>
-            </a:r>
-          </a:p>
-          <a:p>
-            <a:pPr algn="l">
-              <a:spcBef>
-                <a:spcPts val="200"/>
-              </a:spcBef>
-            </a:pPr>
-            <a:r>
-              <a:rPr sz="1300" b="0">
-                <a:solidFill>
-                  <a:srgbClr val="FFFFFF"/>
-                </a:solidFill>
-              </a:rPr>
-              <a:t>Sigma = 0.15  →  15% resolution</a:t>
-            </a:r>
-          </a:p>
-          <a:p>
-            <a:pPr algn="l">
-              <a:spcBef>
-                <a:spcPts val="200"/>
-              </a:spcBef>
-            </a:pPr>
-            <a:r>
-              <a:rPr sz="1300" b="0">
-                <a:solidFill>
-                  <a:srgbClr val="CCCCCC"/>
-                </a:solidFill>
-              </a:rPr>
-              <a:t>                at 1 GeV (expected)</a:t>
-            </a:r>
-          </a:p>
-          <a:p>
-            <a:pPr algn="l">
-              <a:spcBef>
-                <a:spcPts val="200"/>
-              </a:spcBef>
-            </a:pPr>
-            <a:r>
-              <a:rPr sz="1300" b="0">
-                <a:solidFill>
-                  <a:srgbClr val="FFFFFF"/>
-                </a:solidFill>
-              </a:rPr>
-              <a:t>Chi2/NDF = 0.78  →  good fit</a:t>
-            </a:r>
-          </a:p>
-          <a:p>
-            <a:pPr algn="l">
-              <a:spcBef>
-                <a:spcPts val="200"/>
-              </a:spcBef>
-            </a:pPr>
-            <a:r>
-              <a:rPr sz="1300" b="0">
-                <a:solidFill>
-                  <a:srgbClr val="FFFFFF"/>
-                </a:solidFill>
-              </a:rPr>
-              <a:t/>
-            </a:r>
+            <a:endParaRPr sz="1300" b="0">
+              <a:solidFill>
+                <a:srgbClr val="FFFFFF"/>
+              </a:solidFill>
+            </a:endParaRPr>
           </a:p>
           <a:p>
             <a:pPr algn="l">
@@ -6565,7 +6679,7 @@
 </file>
 
 <file path=ppt/slides/slide6.xml><?xml version="1.0" encoding="utf-8"?>
-<p:sld xmlns:a="http://schemas.openxmlformats.org/drawingml/2006/main" xmlns:p="http://schemas.openxmlformats.org/presentationml/2006/main" xmlns:r="http://schemas.openxmlformats.org/officeDocument/2006/relationships">
+<p:sld xmlns:a="http://schemas.openxmlformats.org/drawingml/2006/main" xmlns:r="http://schemas.openxmlformats.org/officeDocument/2006/relationships" xmlns:p="http://schemas.openxmlformats.org/presentationml/2006/main">
   <p:cSld>
     <p:bg>
       <p:bgPr>
@@ -6581,7 +6695,14 @@
         <p:cNvGrpSpPr/>
         <p:nvPr/>
       </p:nvGrpSpPr>
-      <p:grpSpPr/>
+      <p:grpSpPr>
+        <a:xfrm>
+          <a:off x="0" y="0"/>
+          <a:ext cx="0" cy="0"/>
+          <a:chOff x="0" y="0"/>
+          <a:chExt cx="0" cy="0"/>
+        </a:xfrm>
+      </p:grpSpPr>
       <p:sp>
         <p:nvSpPr>
           <p:cNvPr id="2" name="Rectangle 1"/>
@@ -6622,6 +6743,7 @@
           <a:lstStyle/>
           <a:p>
             <a:pPr algn="ctr"/>
+            <a:endParaRPr/>
           </a:p>
         </p:txBody>
       </p:sp>
@@ -6665,6 +6787,7 @@
           <a:lstStyle/>
           <a:p>
             <a:pPr algn="ctr"/>
+            <a:endParaRPr/>
           </a:p>
         </p:txBody>
       </p:sp>
@@ -6772,6 +6895,7 @@
           <a:lstStyle/>
           <a:p>
             <a:pPr algn="ctr"/>
+            <a:endParaRPr/>
           </a:p>
         </p:txBody>
       </p:sp>
@@ -6912,7 +7036,7 @@
 </file>
 
 <file path=ppt/slides/slide7.xml><?xml version="1.0" encoding="utf-8"?>
-<p:sld xmlns:a="http://schemas.openxmlformats.org/drawingml/2006/main" xmlns:p="http://schemas.openxmlformats.org/presentationml/2006/main" xmlns:r="http://schemas.openxmlformats.org/officeDocument/2006/relationships">
+<p:sld xmlns:a="http://schemas.openxmlformats.org/drawingml/2006/main" xmlns:r="http://schemas.openxmlformats.org/officeDocument/2006/relationships" xmlns:p="http://schemas.openxmlformats.org/presentationml/2006/main">
   <p:cSld>
     <p:bg>
       <p:bgPr>
@@ -6928,7 +7052,14 @@
         <p:cNvGrpSpPr/>
         <p:nvPr/>
       </p:nvGrpSpPr>
-      <p:grpSpPr/>
+      <p:grpSpPr>
+        <a:xfrm>
+          <a:off x="0" y="0"/>
+          <a:ext cx="0" cy="0"/>
+          <a:chOff x="0" y="0"/>
+          <a:chExt cx="0" cy="0"/>
+        </a:xfrm>
+      </p:grpSpPr>
       <p:sp>
         <p:nvSpPr>
           <p:cNvPr id="2" name="Rectangle 1"/>
@@ -6969,6 +7100,7 @@
           <a:lstStyle/>
           <a:p>
             <a:pPr algn="ctr"/>
+            <a:endParaRPr/>
           </a:p>
         </p:txBody>
       </p:sp>
@@ -7012,6 +7144,7 @@
           <a:lstStyle/>
           <a:p>
             <a:pPr algn="ctr"/>
+            <a:endParaRPr/>
           </a:p>
         </p:txBody>
       </p:sp>
@@ -7119,6 +7252,7 @@
           <a:lstStyle/>
           <a:p>
             <a:pPr algn="ctr"/>
+            <a:endParaRPr/>
           </a:p>
         </p:txBody>
       </p:sp>
@@ -7259,7 +7393,7 @@
 </file>
 
 <file path=ppt/slides/slide8.xml><?xml version="1.0" encoding="utf-8"?>
-<p:sld xmlns:a="http://schemas.openxmlformats.org/drawingml/2006/main" xmlns:p="http://schemas.openxmlformats.org/presentationml/2006/main" xmlns:r="http://schemas.openxmlformats.org/officeDocument/2006/relationships">
+<p:sld xmlns:a="http://schemas.openxmlformats.org/drawingml/2006/main" xmlns:r="http://schemas.openxmlformats.org/officeDocument/2006/relationships" xmlns:p="http://schemas.openxmlformats.org/presentationml/2006/main">
   <p:cSld>
     <p:bg>
       <p:bgPr>
@@ -7275,7 +7409,14 @@
         <p:cNvGrpSpPr/>
         <p:nvPr/>
       </p:nvGrpSpPr>
-      <p:grpSpPr/>
+      <p:grpSpPr>
+        <a:xfrm>
+          <a:off x="0" y="0"/>
+          <a:ext cx="0" cy="0"/>
+          <a:chOff x="0" y="0"/>
+          <a:chExt cx="0" cy="0"/>
+        </a:xfrm>
+      </p:grpSpPr>
       <p:sp>
         <p:nvSpPr>
           <p:cNvPr id="2" name="Rectangle 1"/>
@@ -7316,6 +7457,7 @@
           <a:lstStyle/>
           <a:p>
             <a:pPr algn="ctr"/>
+            <a:endParaRPr/>
           </a:p>
         </p:txBody>
       </p:sp>
@@ -7359,6 +7501,7 @@
           <a:lstStyle/>
           <a:p>
             <a:pPr algn="ctr"/>
+            <a:endParaRPr/>
           </a:p>
         </p:txBody>
       </p:sp>
@@ -7466,6 +7609,7 @@
           <a:lstStyle/>
           <a:p>
             <a:pPr algn="ctr"/>
+            <a:endParaRPr/>
           </a:p>
         </p:txBody>
       </p:sp>
@@ -7526,14 +7670,11 @@
                 <a:spcPts val="400"/>
               </a:spcBef>
             </a:pPr>
-            <a:r>
-              <a:rPr sz="1500" b="0">
-                <a:solidFill>
-                  <a:srgbClr val="FFFFFF"/>
-                </a:solidFill>
-              </a:rPr>
-              <a:t/>
-            </a:r>
+            <a:endParaRPr sz="1500" b="0">
+              <a:solidFill>
+                <a:srgbClr val="FFFFFF"/>
+              </a:solidFill>
+            </a:endParaRPr>
           </a:p>
           <a:p>
             <a:pPr algn="l">
@@ -7631,14 +7772,11 @@
                 <a:spcPts val="400"/>
               </a:spcBef>
             </a:pPr>
-            <a:r>
-              <a:rPr sz="1500" b="0">
-                <a:solidFill>
-                  <a:srgbClr val="FFFFFF"/>
-                </a:solidFill>
-              </a:rPr>
-              <a:t/>
-            </a:r>
+            <a:endParaRPr sz="1500" b="0">
+              <a:solidFill>
+                <a:srgbClr val="FFFFFF"/>
+              </a:solidFill>
+            </a:endParaRPr>
           </a:p>
           <a:p>
             <a:pPr algn="l">
@@ -7681,7 +7819,7 @@
 </file>
 
 <file path=ppt/slides/slide9.xml><?xml version="1.0" encoding="utf-8"?>
-<p:sld xmlns:a="http://schemas.openxmlformats.org/drawingml/2006/main" xmlns:p="http://schemas.openxmlformats.org/presentationml/2006/main" xmlns:r="http://schemas.openxmlformats.org/officeDocument/2006/relationships">
+<p:sld xmlns:a="http://schemas.openxmlformats.org/drawingml/2006/main" xmlns:r="http://schemas.openxmlformats.org/officeDocument/2006/relationships" xmlns:p="http://schemas.openxmlformats.org/presentationml/2006/main">
   <p:cSld>
     <p:bg>
       <p:bgPr>
@@ -7697,7 +7835,14 @@
         <p:cNvGrpSpPr/>
         <p:nvPr/>
       </p:nvGrpSpPr>
-      <p:grpSpPr/>
+      <p:grpSpPr>
+        <a:xfrm>
+          <a:off x="0" y="0"/>
+          <a:ext cx="0" cy="0"/>
+          <a:chOff x="0" y="0"/>
+          <a:chExt cx="0" cy="0"/>
+        </a:xfrm>
+      </p:grpSpPr>
       <p:sp>
         <p:nvSpPr>
           <p:cNvPr id="2" name="Rectangle 1"/>
@@ -7738,6 +7883,7 @@
           <a:lstStyle/>
           <a:p>
             <a:pPr algn="ctr"/>
+            <a:endParaRPr/>
           </a:p>
         </p:txBody>
       </p:sp>
@@ -7781,6 +7927,7 @@
           <a:lstStyle/>
           <a:p>
             <a:pPr algn="ctr"/>
+            <a:endParaRPr/>
           </a:p>
         </p:txBody>
       </p:sp>
@@ -7888,6 +8035,7 @@
           <a:lstStyle/>
           <a:p>
             <a:pPr algn="ctr"/>
+            <a:endParaRPr/>
           </a:p>
         </p:txBody>
       </p:sp>

</xml_diff>